<commit_message>
Add milestone-gate slide to deck and update video narration
New pitch slide showing the 0.1/0.5/0.8/1.0 cumulative gate ladder, and a
milestone beat added to the 2-minute narration script.

Co-authored-by: Copilot <223556219+Copilot@users.noreply.github.com>
</commit_message>
<xml_diff>
--- a/presentation/Spec-RTL-Sentinel-Pitch.pptx
+++ b/presentation/Spec-RTL-Sentinel-Pitch.pptx
@@ -15,9 +15,10 @@
     <p:sldId id="263" r:id="rId9"/>
     <p:sldId id="264" r:id="rId10"/>
     <p:sldId id="265" r:id="rId11"/>
+    <p:sldId id="266" r:id="rId12"/>
   </p:sldIdLst>
   <p:notesMasterIdLst>
-    <p:notesMasterId r:id="rId12"/>
+    <p:notesMasterId r:id="rId13"/>
   </p:notesMasterIdLst>
   <p:sldSz cx="12192000" cy="6858000"/>
   <p:notesSz cx="6858000" cy="12192000"/>
@@ -641,6 +642,94 @@
 </p:notes>
 </file>
 
+<file path=ppt/notesSlides/notesSlide11.xml><?xml version="1.0" encoding="utf-8"?>
+<p:notes xmlns:a="http://schemas.openxmlformats.org/drawingml/2006/main" xmlns:r="http://schemas.openxmlformats.org/officeDocument/2006/relationships" xmlns:p="http://schemas.openxmlformats.org/presentationml/2006/main">
+  <p:cSld>
+    <p:spTree>
+      <p:nvGrpSpPr>
+        <p:cNvPr id="1" name=""/>
+        <p:cNvGrpSpPr/>
+        <p:nvPr/>
+      </p:nvGrpSpPr>
+      <p:grpSpPr>
+        <a:xfrm>
+          <a:off x="0" y="0"/>
+          <a:ext cx="0" cy="0"/>
+          <a:chOff x="0" y="0"/>
+          <a:chExt cx="0" cy="0"/>
+        </a:xfrm>
+      </p:grpSpPr>
+      <p:sp>
+        <p:nvSpPr>
+          <p:cNvPr id="2" name="Slide Image Placeholder 1"/>
+          <p:cNvSpPr>
+            <a:spLocks noGrp="1" noRot="1" noChangeAspect="1"/>
+          </p:cNvSpPr>
+          <p:nvPr>
+            <p:ph type="sldImg"/>
+          </p:nvPr>
+        </p:nvSpPr>
+        <p:spPr/>
+      </p:sp>
+      <p:sp>
+        <p:nvSpPr>
+          <p:cNvPr id="3" name="Notes Placeholder 2"/>
+          <p:cNvSpPr>
+            <a:spLocks noGrp="1"/>
+          </p:cNvSpPr>
+          <p:nvPr>
+            <p:ph type="body" idx="1"/>
+          </p:nvPr>
+        </p:nvSpPr>
+        <p:spPr/>
+        <p:txBody>
+          <a:bodyPr/>
+          <a:lstStyle/>
+          <a:p>
+            <a:r>
+              <a:rPr lang="en-US" dirty="0"/>
+              <a:t/>
+            </a:r>
+            <a:endParaRPr lang="en-US" dirty="0"/>
+          </a:p>
+        </p:txBody>
+      </p:sp>
+      <p:sp>
+        <p:nvSpPr>
+          <p:cNvPr id="4" name="Slide Number Placeholder 3"/>
+          <p:cNvSpPr>
+            <a:spLocks noGrp="1"/>
+          </p:cNvSpPr>
+          <p:nvPr>
+            <p:ph type="sldNum" sz="quarter" idx="10"/>
+          </p:nvPr>
+        </p:nvSpPr>
+        <p:spPr/>
+        <p:txBody>
+          <a:bodyPr/>
+          <a:lstStyle/>
+          <a:p>
+            <a:fld id="{F7021451-1387-4CA6-816F-3879F97B5CBC}" type="slidenum">
+              <a:rPr lang="en-US"/>
+              <a:t>11</a:t>
+            </a:fld>
+            <a:endParaRPr lang="en-US"/>
+          </a:p>
+        </p:txBody>
+      </p:sp>
+    </p:spTree>
+    <p:extLst>
+      <p:ext uri="{BB962C8B-B14F-4D97-AF65-F5344CB8AC3E}">
+        <p14:creationId xmlns:p14="http://schemas.microsoft.com/office/powerpoint/2010/main" val="1024086991"/>
+      </p:ext>
+    </p:extLst>
+  </p:cSld>
+  <p:clrMapOvr>
+    <a:masterClrMapping/>
+  </p:clrMapOvr>
+</p:notes>
+</file>
+
 <file path=ppt/notesSlides/notesSlide2.xml><?xml version="1.0" encoding="utf-8"?>
 <p:notes xmlns:a="http://schemas.openxmlformats.org/drawingml/2006/main" xmlns:r="http://schemas.openxmlformats.org/officeDocument/2006/relationships" xmlns:p="http://schemas.openxmlformats.org/presentationml/2006/main">
   <p:cSld>
@@ -2261,6 +2350,629 @@
     <p:bg>
       <p:bgPr>
         <a:solidFill>
+          <a:srgbClr val="F4F8FC"/>
+        </a:solidFill>
+      </p:bgPr>
+    </p:bg>
+    <p:spTree>
+      <p:nvGrpSpPr>
+        <p:cNvPr id="1" name=""/>
+        <p:cNvGrpSpPr/>
+        <p:nvPr/>
+      </p:nvGrpSpPr>
+      <p:grpSpPr>
+        <a:xfrm>
+          <a:off x="0" y="0"/>
+          <a:ext cx="0" cy="0"/>
+          <a:chOff x="0" y="0"/>
+          <a:chExt cx="0" cy="0"/>
+        </a:xfrm>
+      </p:grpSpPr>
+      <p:sp>
+        <p:nvSpPr>
+          <p:cNvPr id="2" name="Shape 0"/>
+          <p:cNvSpPr/>
+          <p:nvPr/>
+        </p:nvSpPr>
+        <p:spPr>
+          <a:xfrm>
+            <a:off x="548640" y="566928"/>
+            <a:ext cx="146304" cy="146304"/>
+          </a:xfrm>
+          <a:prstGeom prst="ellipse">
+            <a:avLst/>
+          </a:prstGeom>
+          <a:solidFill>
+            <a:srgbClr val="0C8599"/>
+          </a:solidFill>
+          <a:ln/>
+        </p:spPr>
+      </p:sp>
+      <p:sp>
+        <p:nvSpPr>
+          <p:cNvPr id="3" name="Text 1"/>
+          <p:cNvSpPr/>
+          <p:nvPr/>
+        </p:nvSpPr>
+        <p:spPr>
+          <a:xfrm>
+            <a:off x="777240" y="457200"/>
+            <a:ext cx="8229600" cy="365760"/>
+          </a:xfrm>
+          <a:prstGeom prst="rect">
+            <a:avLst/>
+          </a:prstGeom>
+          <a:noFill/>
+          <a:ln/>
+        </p:spPr>
+        <p:txBody>
+          <a:bodyPr wrap="square" lIns="0" tIns="0" rIns="0" bIns="0" rtlCol="0" anchor="ctr"/>
+          <a:lstStyle/>
+          <a:p>
+            <a:pPr algn="l" indent="0" marL="0">
+              <a:buNone/>
+            </a:pPr>
+            <a:r>
+              <a:rPr lang="en-US" sz="1300" b="1" spc="300" kern="0" dirty="0">
+                <a:solidFill>
+                  <a:srgbClr val="0C8599"/>
+                </a:solidFill>
+                <a:latin typeface="Trebuchet MS" pitchFamily="34" charset="0"/>
+                <a:ea typeface="Trebuchet MS" pitchFamily="34" charset="-122"/>
+                <a:cs typeface="Trebuchet MS" pitchFamily="34" charset="-120"/>
+              </a:rPr>
+              <a:t>IMPACT</a:t>
+            </a:r>
+            <a:endParaRPr lang="en-US" sz="1300" dirty="0"/>
+          </a:p>
+        </p:txBody>
+      </p:sp>
+      <p:sp>
+        <p:nvSpPr>
+          <p:cNvPr id="4" name="Text 2"/>
+          <p:cNvSpPr/>
+          <p:nvPr/>
+        </p:nvSpPr>
+        <p:spPr>
+          <a:xfrm>
+            <a:off x="530352" y="822960"/>
+            <a:ext cx="11064240" cy="868680"/>
+          </a:xfrm>
+          <a:prstGeom prst="rect">
+            <a:avLst/>
+          </a:prstGeom>
+          <a:noFill/>
+          <a:ln/>
+        </p:spPr>
+        <p:txBody>
+          <a:bodyPr wrap="square" lIns="0" tIns="0" rIns="0" bIns="0" rtlCol="0" anchor="ctr"/>
+          <a:lstStyle/>
+          <a:p>
+            <a:pPr algn="l" indent="0" marL="0">
+              <a:buNone/>
+            </a:pPr>
+            <a:r>
+              <a:rPr lang="en-US" sz="3000" b="1" dirty="0">
+                <a:solidFill>
+                  <a:srgbClr val="12324F"/>
+                </a:solidFill>
+                <a:latin typeface="Trebuchet MS" pitchFamily="34" charset="0"/>
+                <a:ea typeface="Trebuchet MS" pitchFamily="34" charset="-122"/>
+                <a:cs typeface="Trebuchet MS" pitchFamily="34" charset="-120"/>
+              </a:rPr>
+              <a:t>From hours of review to seconds</a:t>
+            </a:r>
+            <a:endParaRPr lang="en-US" sz="3000" dirty="0"/>
+          </a:p>
+        </p:txBody>
+      </p:sp>
+      <p:sp>
+        <p:nvSpPr>
+          <p:cNvPr id="5" name="Shape 3"/>
+          <p:cNvSpPr/>
+          <p:nvPr/>
+        </p:nvSpPr>
+        <p:spPr>
+          <a:xfrm>
+            <a:off x="640080" y="1920240"/>
+            <a:ext cx="3566160" cy="1737360"/>
+          </a:xfrm>
+          <a:prstGeom prst="roundRect">
+            <a:avLst>
+              <a:gd name="adj" fmla="val 4211"/>
+            </a:avLst>
+          </a:prstGeom>
+          <a:solidFill>
+            <a:srgbClr val="FFFFFF"/>
+          </a:solidFill>
+          <a:ln w="12700">
+            <a:solidFill>
+              <a:srgbClr val="D7E1EC"/>
+            </a:solidFill>
+            <a:prstDash val="solid"/>
+          </a:ln>
+          <a:effectLst>
+            <a:outerShdw sx="100000" sy="100000" kx="0" ky="0" algn="bl" rotWithShape="0" blurRad="101600" dist="38100" dir="5400000">
+              <a:srgbClr val="1E2733">
+                <a:alpha val="12000"/>
+              </a:srgbClr>
+            </a:outerShdw>
+          </a:effectLst>
+        </p:spPr>
+      </p:sp>
+      <p:sp>
+        <p:nvSpPr>
+          <p:cNvPr id="6" name="Text 4"/>
+          <p:cNvSpPr/>
+          <p:nvPr/>
+        </p:nvSpPr>
+        <p:spPr>
+          <a:xfrm>
+            <a:off x="914400" y="2148840"/>
+            <a:ext cx="3017520" cy="868680"/>
+          </a:xfrm>
+          <a:prstGeom prst="rect">
+            <a:avLst/>
+          </a:prstGeom>
+          <a:noFill/>
+          <a:ln/>
+        </p:spPr>
+        <p:txBody>
+          <a:bodyPr wrap="square" lIns="0" tIns="0" rIns="0" bIns="0" rtlCol="0" anchor="ctr"/>
+          <a:lstStyle/>
+          <a:p>
+            <a:pPr algn="l" indent="0" marL="0">
+              <a:buNone/>
+            </a:pPr>
+            <a:r>
+              <a:rPr lang="en-US" sz="4000" b="1" dirty="0">
+                <a:solidFill>
+                  <a:srgbClr val="0C8599"/>
+                </a:solidFill>
+                <a:latin typeface="Trebuchet MS" pitchFamily="34" charset="0"/>
+                <a:ea typeface="Trebuchet MS" pitchFamily="34" charset="-122"/>
+                <a:cs typeface="Trebuchet MS" pitchFamily="34" charset="-120"/>
+              </a:rPr>
+              <a:t>seconds</a:t>
+            </a:r>
+            <a:endParaRPr lang="en-US" sz="4000" dirty="0"/>
+          </a:p>
+        </p:txBody>
+      </p:sp>
+      <p:sp>
+        <p:nvSpPr>
+          <p:cNvPr id="7" name="Text 5"/>
+          <p:cNvSpPr/>
+          <p:nvPr/>
+        </p:nvSpPr>
+        <p:spPr>
+          <a:xfrm>
+            <a:off x="932688" y="3063240"/>
+            <a:ext cx="3108960" cy="502920"/>
+          </a:xfrm>
+          <a:prstGeom prst="rect">
+            <a:avLst/>
+          </a:prstGeom>
+          <a:noFill/>
+          <a:ln/>
+        </p:spPr>
+        <p:txBody>
+          <a:bodyPr wrap="square" lIns="0" tIns="0" rIns="0" bIns="0" rtlCol="0" anchor="ctr"/>
+          <a:lstStyle/>
+          <a:p>
+            <a:pPr algn="l" indent="0" marL="0">
+              <a:buNone/>
+            </a:pPr>
+            <a:r>
+              <a:rPr lang="en-US" sz="1350" dirty="0">
+                <a:solidFill>
+                  <a:srgbClr val="5A6473"/>
+                </a:solidFill>
+                <a:latin typeface="Calibri" pitchFamily="34" charset="0"/>
+                <a:ea typeface="Calibri" pitchFamily="34" charset="-122"/>
+                <a:cs typeface="Calibri" pitchFamily="34" charset="-120"/>
+              </a:rPr>
+              <a:t>to audit RTL against 4 intent layers</a:t>
+            </a:r>
+            <a:endParaRPr lang="en-US" sz="1350" dirty="0"/>
+          </a:p>
+        </p:txBody>
+      </p:sp>
+      <p:sp>
+        <p:nvSpPr>
+          <p:cNvPr id="8" name="Shape 6"/>
+          <p:cNvSpPr/>
+          <p:nvPr/>
+        </p:nvSpPr>
+        <p:spPr>
+          <a:xfrm>
+            <a:off x="4343400" y="1920240"/>
+            <a:ext cx="3566160" cy="1737360"/>
+          </a:xfrm>
+          <a:prstGeom prst="roundRect">
+            <a:avLst>
+              <a:gd name="adj" fmla="val 4211"/>
+            </a:avLst>
+          </a:prstGeom>
+          <a:solidFill>
+            <a:srgbClr val="FFFFFF"/>
+          </a:solidFill>
+          <a:ln w="12700">
+            <a:solidFill>
+              <a:srgbClr val="D7E1EC"/>
+            </a:solidFill>
+            <a:prstDash val="solid"/>
+          </a:ln>
+          <a:effectLst>
+            <a:outerShdw sx="100000" sy="100000" kx="0" ky="0" algn="bl" rotWithShape="0" blurRad="101600" dist="38100" dir="5400000">
+              <a:srgbClr val="1E2733">
+                <a:alpha val="12000"/>
+              </a:srgbClr>
+            </a:outerShdw>
+          </a:effectLst>
+        </p:spPr>
+      </p:sp>
+      <p:sp>
+        <p:nvSpPr>
+          <p:cNvPr id="9" name="Text 7"/>
+          <p:cNvSpPr/>
+          <p:nvPr/>
+        </p:nvSpPr>
+        <p:spPr>
+          <a:xfrm>
+            <a:off x="4617720" y="2148840"/>
+            <a:ext cx="3017520" cy="868680"/>
+          </a:xfrm>
+          <a:prstGeom prst="rect">
+            <a:avLst/>
+          </a:prstGeom>
+          <a:noFill/>
+          <a:ln/>
+        </p:spPr>
+        <p:txBody>
+          <a:bodyPr wrap="square" lIns="0" tIns="0" rIns="0" bIns="0" rtlCol="0" anchor="ctr"/>
+          <a:lstStyle/>
+          <a:p>
+            <a:pPr algn="l" indent="0" marL="0">
+              <a:buNone/>
+            </a:pPr>
+            <a:r>
+              <a:rPr lang="en-US" sz="4000" b="1" dirty="0">
+                <a:solidFill>
+                  <a:srgbClr val="12324F"/>
+                </a:solidFill>
+                <a:latin typeface="Trebuchet MS" pitchFamily="34" charset="0"/>
+                <a:ea typeface="Trebuchet MS" pitchFamily="34" charset="-122"/>
+                <a:cs typeface="Trebuchet MS" pitchFamily="34" charset="-120"/>
+              </a:rPr>
+              <a:t>100%</a:t>
+            </a:r>
+            <a:endParaRPr lang="en-US" sz="4000" dirty="0"/>
+          </a:p>
+        </p:txBody>
+      </p:sp>
+      <p:sp>
+        <p:nvSpPr>
+          <p:cNvPr id="10" name="Text 8"/>
+          <p:cNvSpPr/>
+          <p:nvPr/>
+        </p:nvSpPr>
+        <p:spPr>
+          <a:xfrm>
+            <a:off x="4636008" y="3063240"/>
+            <a:ext cx="3108960" cy="502920"/>
+          </a:xfrm>
+          <a:prstGeom prst="rect">
+            <a:avLst/>
+          </a:prstGeom>
+          <a:noFill/>
+          <a:ln/>
+        </p:spPr>
+        <p:txBody>
+          <a:bodyPr wrap="square" lIns="0" tIns="0" rIns="0" bIns="0" rtlCol="0" anchor="ctr"/>
+          <a:lstStyle/>
+          <a:p>
+            <a:pPr algn="l" indent="0" marL="0">
+              <a:buNone/>
+            </a:pPr>
+            <a:r>
+              <a:rPr lang="en-US" sz="1350" dirty="0">
+                <a:solidFill>
+                  <a:srgbClr val="5A6473"/>
+                </a:solidFill>
+                <a:latin typeface="Calibri" pitchFamily="34" charset="0"/>
+                <a:ea typeface="Calibri" pitchFamily="34" charset="-122"/>
+                <a:cs typeface="Calibri" pitchFamily="34" charset="-120"/>
+              </a:rPr>
+              <a:t>of findings source-cited</a:t>
+            </a:r>
+            <a:endParaRPr lang="en-US" sz="1350" dirty="0"/>
+          </a:p>
+        </p:txBody>
+      </p:sp>
+      <p:sp>
+        <p:nvSpPr>
+          <p:cNvPr id="11" name="Shape 9"/>
+          <p:cNvSpPr/>
+          <p:nvPr/>
+        </p:nvSpPr>
+        <p:spPr>
+          <a:xfrm>
+            <a:off x="8046720" y="1920240"/>
+            <a:ext cx="3566160" cy="1737360"/>
+          </a:xfrm>
+          <a:prstGeom prst="roundRect">
+            <a:avLst>
+              <a:gd name="adj" fmla="val 4211"/>
+            </a:avLst>
+          </a:prstGeom>
+          <a:solidFill>
+            <a:srgbClr val="FFFFFF"/>
+          </a:solidFill>
+          <a:ln w="12700">
+            <a:solidFill>
+              <a:srgbClr val="D7E1EC"/>
+            </a:solidFill>
+            <a:prstDash val="solid"/>
+          </a:ln>
+          <a:effectLst>
+            <a:outerShdw sx="100000" sy="100000" kx="0" ky="0" algn="bl" rotWithShape="0" blurRad="101600" dist="38100" dir="5400000">
+              <a:srgbClr val="1E2733">
+                <a:alpha val="12000"/>
+              </a:srgbClr>
+            </a:outerShdw>
+          </a:effectLst>
+        </p:spPr>
+      </p:sp>
+      <p:sp>
+        <p:nvSpPr>
+          <p:cNvPr id="12" name="Text 10"/>
+          <p:cNvSpPr/>
+          <p:nvPr/>
+        </p:nvSpPr>
+        <p:spPr>
+          <a:xfrm>
+            <a:off x="8321040" y="2148840"/>
+            <a:ext cx="3017520" cy="868680"/>
+          </a:xfrm>
+          <a:prstGeom prst="rect">
+            <a:avLst/>
+          </a:prstGeom>
+          <a:noFill/>
+          <a:ln/>
+        </p:spPr>
+        <p:txBody>
+          <a:bodyPr wrap="square" lIns="0" tIns="0" rIns="0" bIns="0" rtlCol="0" anchor="ctr"/>
+          <a:lstStyle/>
+          <a:p>
+            <a:pPr algn="l" indent="0" marL="0">
+              <a:buNone/>
+            </a:pPr>
+            <a:r>
+              <a:rPr lang="en-US" sz="4000" b="1" dirty="0">
+                <a:solidFill>
+                  <a:srgbClr val="0C6B78"/>
+                </a:solidFill>
+                <a:latin typeface="Trebuchet MS" pitchFamily="34" charset="0"/>
+                <a:ea typeface="Trebuchet MS" pitchFamily="34" charset="-122"/>
+                <a:cs typeface="Trebuchet MS" pitchFamily="34" charset="-120"/>
+              </a:rPr>
+              <a:t>0</a:t>
+            </a:r>
+            <a:endParaRPr lang="en-US" sz="4000" dirty="0"/>
+          </a:p>
+        </p:txBody>
+      </p:sp>
+      <p:sp>
+        <p:nvSpPr>
+          <p:cNvPr id="13" name="Text 11"/>
+          <p:cNvSpPr/>
+          <p:nvPr/>
+        </p:nvSpPr>
+        <p:spPr>
+          <a:xfrm>
+            <a:off x="8339328" y="3063240"/>
+            <a:ext cx="3108960" cy="502920"/>
+          </a:xfrm>
+          <a:prstGeom prst="rect">
+            <a:avLst/>
+          </a:prstGeom>
+          <a:noFill/>
+          <a:ln/>
+        </p:spPr>
+        <p:txBody>
+          <a:bodyPr wrap="square" lIns="0" tIns="0" rIns="0" bIns="0" rtlCol="0" anchor="ctr"/>
+          <a:lstStyle/>
+          <a:p>
+            <a:pPr algn="l" indent="0" marL="0">
+              <a:buNone/>
+            </a:pPr>
+            <a:r>
+              <a:rPr lang="en-US" sz="1350" dirty="0">
+                <a:solidFill>
+                  <a:srgbClr val="5A6473"/>
+                </a:solidFill>
+                <a:latin typeface="Calibri" pitchFamily="34" charset="0"/>
+                <a:ea typeface="Calibri" pitchFamily="34" charset="-122"/>
+                <a:cs typeface="Calibri" pitchFamily="34" charset="-120"/>
+              </a:rPr>
+              <a:t>API keys — runs fully offline</a:t>
+            </a:r>
+            <a:endParaRPr lang="en-US" sz="1350" dirty="0"/>
+          </a:p>
+        </p:txBody>
+      </p:sp>
+      <p:sp>
+        <p:nvSpPr>
+          <p:cNvPr id="14" name="Text 12"/>
+          <p:cNvSpPr/>
+          <p:nvPr/>
+        </p:nvSpPr>
+        <p:spPr>
+          <a:xfrm>
+            <a:off x="640080" y="3977640"/>
+            <a:ext cx="5486400" cy="457200"/>
+          </a:xfrm>
+          <a:prstGeom prst="rect">
+            <a:avLst/>
+          </a:prstGeom>
+          <a:noFill/>
+          <a:ln/>
+        </p:spPr>
+        <p:txBody>
+          <a:bodyPr wrap="square" lIns="0" tIns="0" rIns="0" bIns="0" rtlCol="0" anchor="ctr"/>
+          <a:lstStyle/>
+          <a:p>
+            <a:pPr indent="0" marL="0">
+              <a:buNone/>
+            </a:pPr>
+            <a:r>
+              <a:rPr lang="en-US" sz="1800" b="1" dirty="0">
+                <a:solidFill>
+                  <a:srgbClr val="12324F"/>
+                </a:solidFill>
+                <a:latin typeface="Trebuchet MS" pitchFamily="34" charset="0"/>
+                <a:ea typeface="Trebuchet MS" pitchFamily="34" charset="-122"/>
+                <a:cs typeface="Trebuchet MS" pitchFamily="34" charset="-120"/>
+              </a:rPr>
+              <a:t>Who benefits</a:t>
+            </a:r>
+            <a:endParaRPr lang="en-US" sz="1800" dirty="0"/>
+          </a:p>
+        </p:txBody>
+      </p:sp>
+      <p:sp>
+        <p:nvSpPr>
+          <p:cNvPr id="15" name="Text 13"/>
+          <p:cNvSpPr/>
+          <p:nvPr/>
+        </p:nvSpPr>
+        <p:spPr>
+          <a:xfrm>
+            <a:off x="640080" y="4480560"/>
+            <a:ext cx="10881360" cy="2011680"/>
+          </a:xfrm>
+          <a:prstGeom prst="rect">
+            <a:avLst/>
+          </a:prstGeom>
+          <a:noFill/>
+          <a:ln/>
+        </p:spPr>
+        <p:txBody>
+          <a:bodyPr wrap="square" rtlCol="0" anchor="ctr"/>
+          <a:lstStyle/>
+          <a:p>
+            <a:pPr marL="342900" indent="-342900">
+              <a:lnSpc>
+                <a:spcPct val="115000"/>
+              </a:lnSpc>
+              <a:spcAft>
+                <a:spcPts val="800"/>
+              </a:spcAft>
+              <a:buSzPct val="100000"/>
+              <a:buChar char="•"/>
+            </a:pPr>
+            <a:r>
+              <a:rPr lang="en-US" sz="1600" dirty="0">
+                <a:solidFill>
+                  <a:srgbClr val="1E2733"/>
+                </a:solidFill>
+                <a:latin typeface="Calibri" pitchFamily="34" charset="0"/>
+                <a:ea typeface="Calibri" pitchFamily="34" charset="-122"/>
+                <a:cs typeface="Calibri" pitchFamily="34" charset="-120"/>
+              </a:rPr>
+              <a:t>Design &amp; verification engineers — stop hand-diffing specs against RTL</a:t>
+            </a:r>
+            <a:endParaRPr lang="en-US" sz="1600" dirty="0"/>
+          </a:p>
+          <a:p>
+            <a:pPr marL="342900" indent="-342900">
+              <a:lnSpc>
+                <a:spcPct val="115000"/>
+              </a:lnSpc>
+              <a:spcAft>
+                <a:spcPts val="800"/>
+              </a:spcAft>
+              <a:buSzPct val="100000"/>
+              <a:buChar char="•"/>
+            </a:pPr>
+            <a:r>
+              <a:rPr lang="en-US" sz="1600" dirty="0">
+                <a:solidFill>
+                  <a:srgbClr val="1E2733"/>
+                </a:solidFill>
+                <a:latin typeface="Calibri" pitchFamily="34" charset="0"/>
+                <a:ea typeface="Calibri" pitchFamily="34" charset="-122"/>
+                <a:cs typeface="Calibri" pitchFamily="34" charset="-120"/>
+              </a:rPr>
+              <a:t>Architects — see which top-level requirements are actually implemented</a:t>
+            </a:r>
+            <a:endParaRPr lang="en-US" sz="1600" dirty="0"/>
+          </a:p>
+          <a:p>
+            <a:pPr marL="342900" indent="-342900">
+              <a:lnSpc>
+                <a:spcPct val="115000"/>
+              </a:lnSpc>
+              <a:spcAft>
+                <a:spcPts val="800"/>
+              </a:spcAft>
+              <a:buSzPct val="100000"/>
+              <a:buChar char="•"/>
+            </a:pPr>
+            <a:r>
+              <a:rPr lang="en-US" sz="1600" dirty="0">
+                <a:solidFill>
+                  <a:srgbClr val="1E2733"/>
+                </a:solidFill>
+                <a:latin typeface="Calibri" pitchFamily="34" charset="0"/>
+                <a:ea typeface="Calibri" pitchFamily="34" charset="-122"/>
+                <a:cs typeface="Calibri" pitchFamily="34" charset="-120"/>
+              </a:rPr>
+              <a:t>Leads &amp; PMs — a living drift metric per commit, not a one-time review</a:t>
+            </a:r>
+            <a:endParaRPr lang="en-US" sz="1600" dirty="0"/>
+          </a:p>
+          <a:p>
+            <a:pPr marL="342900" indent="-342900">
+              <a:lnSpc>
+                <a:spcPct val="115000"/>
+              </a:lnSpc>
+              <a:spcAft>
+                <a:spcPts val="800"/>
+              </a:spcAft>
+              <a:buSzPct val="100000"/>
+              <a:buChar char="•"/>
+            </a:pPr>
+            <a:r>
+              <a:rPr lang="en-US" sz="1600" dirty="0">
+                <a:solidFill>
+                  <a:srgbClr val="1E2733"/>
+                </a:solidFill>
+                <a:latin typeface="Calibri" pitchFamily="34" charset="0"/>
+                <a:ea typeface="Calibri" pitchFamily="34" charset="-122"/>
+                <a:cs typeface="Calibri" pitchFamily="34" charset="-120"/>
+              </a:rPr>
+              <a:t>Security IP teams — catch key/register drift before tapeout</a:t>
+            </a:r>
+            <a:endParaRPr lang="en-US" sz="1600" dirty="0"/>
+          </a:p>
+        </p:txBody>
+      </p:sp>
+    </p:spTree>
+  </p:cSld>
+  <p:clrMapOvr>
+    <a:masterClrMapping/>
+  </p:clrMapOvr>
+</p:sld>
+</file>
+
+<file path=ppt/slides/slide11.xml><?xml version="1.0" encoding="utf-8"?>
+<p:sld xmlns:a="http://schemas.openxmlformats.org/drawingml/2006/main" xmlns:r="http://schemas.openxmlformats.org/officeDocument/2006/relationships" xmlns:p="http://schemas.openxmlformats.org/presentationml/2006/main">
+  <p:cSld name="Slide 11">
+    <p:bg>
+      <p:bgPr>
+        <a:solidFill>
           <a:srgbClr val="12324F"/>
         </a:solidFill>
       </p:bgPr>
@@ -7645,7 +8357,7 @@
                 <a:ea typeface="Trebuchet MS" pitchFamily="34" charset="-122"/>
                 <a:cs typeface="Trebuchet MS" pitchFamily="34" charset="-120"/>
               </a:rPr>
-              <a:t>WHY IT'S DIFFERENT</a:t>
+              <a:t>MILESTONE GATES</a:t>
             </a:r>
             <a:endParaRPr lang="en-US" sz="1300" dirty="0"/>
           </a:p>
@@ -7684,7 +8396,7 @@
                 <a:ea typeface="Trebuchet MS" pitchFamily="34" charset="-122"/>
                 <a:cs typeface="Trebuchet MS" pitchFamily="34" charset="-120"/>
               </a:rPr>
-              <a:t>Grounded. Traceable. Trustworthy.</a:t>
+              <a:t>Is the RTL 0.1-clean? 0.5-clean?</a:t>
             </a:r>
             <a:endParaRPr lang="en-US" sz="3000" dirty="0"/>
           </a:p>
@@ -7692,18 +8404,71 @@
       </p:sp>
       <p:sp>
         <p:nvSpPr>
-          <p:cNvPr id="5" name="Shape 3"/>
-          <p:cNvSpPr/>
-          <p:nvPr/>
-        </p:nvSpPr>
-        <p:spPr>
-          <a:xfrm>
-            <a:off x="640080" y="2011680"/>
-            <a:ext cx="3566160" cy="3840480"/>
+          <p:cNvPr id="5" name="Text 3"/>
+          <p:cNvSpPr/>
+          <p:nvPr/>
+        </p:nvSpPr>
+        <p:spPr>
+          <a:xfrm>
+            <a:off x="640080" y="1737360"/>
+            <a:ext cx="10881360" cy="640080"/>
+          </a:xfrm>
+          <a:prstGeom prst="rect">
+            <a:avLst/>
+          </a:prstGeom>
+          <a:noFill/>
+          <a:ln/>
+        </p:spPr>
+        <p:txBody>
+          <a:bodyPr wrap="square" lIns="0" tIns="0" rIns="0" bIns="0" rtlCol="0" anchor="ctr"/>
+          <a:lstStyle/>
+          <a:p>
+            <a:pPr indent="0" marL="0">
+              <a:buNone/>
+            </a:pPr>
+            <a:r>
+              <a:rPr lang="en-US" sz="1600" b="1" dirty="0">
+                <a:solidFill>
+                  <a:srgbClr val="12324F"/>
+                </a:solidFill>
+                <a:latin typeface="Calibri" pitchFamily="34" charset="0"/>
+                <a:ea typeface="Calibri" pitchFamily="34" charset="-122"/>
+                <a:cs typeface="Calibri" pitchFamily="34" charset="-120"/>
+              </a:rPr>
+              <a:t>HAS is the golden reference — never flagged. </a:t>
+            </a:r>
+            <a:pPr indent="0" marL="0">
+              <a:buNone/>
+            </a:pPr>
+            <a:r>
+              <a:rPr lang="en-US" sz="1600" dirty="0">
+                <a:solidFill>
+                  <a:srgbClr val="1E2733"/>
+                </a:solidFill>
+                <a:latin typeface="Calibri" pitchFamily="34" charset="0"/>
+                <a:ea typeface="Calibri" pitchFamily="34" charset="-122"/>
+                <a:cs typeface="Calibri" pitchFamily="34" charset="-120"/>
+              </a:rPr>
+              <a:t>MAS and RTL are checked against it milestone by milestone, so each stage only checks what should be done by then.</a:t>
+            </a:r>
+            <a:endParaRPr lang="en-US" sz="1600" dirty="0"/>
+          </a:p>
+        </p:txBody>
+      </p:sp>
+      <p:sp>
+        <p:nvSpPr>
+          <p:cNvPr id="6" name="Shape 4"/>
+          <p:cNvSpPr/>
+          <p:nvPr/>
+        </p:nvSpPr>
+        <p:spPr>
+          <a:xfrm>
+            <a:off x="640080" y="2514600"/>
+            <a:ext cx="8229600" cy="841248"/>
           </a:xfrm>
           <a:prstGeom prst="roundRect">
             <a:avLst>
-              <a:gd name="adj" fmla="val 2051"/>
+              <a:gd name="adj" fmla="val 8696"/>
             </a:avLst>
           </a:prstGeom>
           <a:solidFill>
@@ -7726,34 +8491,54 @@
       </p:sp>
       <p:sp>
         <p:nvSpPr>
-          <p:cNvPr id="6" name="Shape 4"/>
-          <p:cNvSpPr/>
-          <p:nvPr/>
-        </p:nvSpPr>
-        <p:spPr>
-          <a:xfrm>
-            <a:off x="960120" y="2377440"/>
-            <a:ext cx="731520" cy="731520"/>
+          <p:cNvPr id="7" name="Shape 5"/>
+          <p:cNvSpPr/>
+          <p:nvPr/>
+        </p:nvSpPr>
+        <p:spPr>
+          <a:xfrm>
+            <a:off x="640080" y="2514600"/>
+            <a:ext cx="118872" cy="841248"/>
+          </a:xfrm>
+          <a:prstGeom prst="rect">
+            <a:avLst/>
+          </a:prstGeom>
+          <a:solidFill>
+            <a:srgbClr val="B01722"/>
+          </a:solidFill>
+          <a:ln/>
+        </p:spPr>
+      </p:sp>
+      <p:sp>
+        <p:nvSpPr>
+          <p:cNvPr id="8" name="Shape 6"/>
+          <p:cNvSpPr/>
+          <p:nvPr/>
+        </p:nvSpPr>
+        <p:spPr>
+          <a:xfrm>
+            <a:off x="868680" y="2697480"/>
+            <a:ext cx="475488" cy="475488"/>
           </a:xfrm>
           <a:prstGeom prst="ellipse">
             <a:avLst/>
           </a:prstGeom>
           <a:solidFill>
-            <a:srgbClr val="0C8599"/>
-          </a:solidFill>
-          <a:ln/>
-        </p:spPr>
-      </p:sp>
-      <p:sp>
-        <p:nvSpPr>
-          <p:cNvPr id="7" name="Text 5"/>
-          <p:cNvSpPr/>
-          <p:nvPr/>
-        </p:nvSpPr>
-        <p:spPr>
-          <a:xfrm>
-            <a:off x="960120" y="2377440"/>
-            <a:ext cx="731520" cy="731520"/>
+            <a:srgbClr val="12324F"/>
+          </a:solidFill>
+          <a:ln/>
+        </p:spPr>
+      </p:sp>
+      <p:sp>
+        <p:nvSpPr>
+          <p:cNvPr id="9" name="Text 7"/>
+          <p:cNvSpPr/>
+          <p:nvPr/>
+        </p:nvSpPr>
+        <p:spPr>
+          <a:xfrm>
+            <a:off x="868680" y="2697480"/>
+            <a:ext cx="475488" cy="475488"/>
           </a:xfrm>
           <a:prstGeom prst="rect">
             <a:avLst/>
@@ -7769,7 +8554,7 @@
               <a:buNone/>
             </a:pPr>
             <a:r>
-              <a:rPr lang="en-US" sz="3000" b="1" dirty="0">
+              <a:rPr lang="en-US" sz="1400" b="1" dirty="0">
                 <a:solidFill>
                   <a:srgbClr val="FFFFFF"/>
                 </a:solidFill>
@@ -7777,22 +8562,22 @@
                 <a:ea typeface="Trebuchet MS" pitchFamily="34" charset="-122"/>
                 <a:cs typeface="Trebuchet MS" pitchFamily="34" charset="-120"/>
               </a:rPr>
-              <a:t>✓</a:t>
-            </a:r>
-            <a:endParaRPr lang="en-US" sz="3000" dirty="0"/>
-          </a:p>
-        </p:txBody>
-      </p:sp>
-      <p:sp>
-        <p:nvSpPr>
-          <p:cNvPr id="8" name="Text 6"/>
-          <p:cNvSpPr/>
-          <p:nvPr/>
-        </p:nvSpPr>
-        <p:spPr>
-          <a:xfrm>
-            <a:off x="914400" y="3291840"/>
-            <a:ext cx="3017520" cy="822960"/>
+              <a:t>0.1</a:t>
+            </a:r>
+            <a:endParaRPr lang="en-US" sz="1400" dirty="0"/>
+          </a:p>
+        </p:txBody>
+      </p:sp>
+      <p:sp>
+        <p:nvSpPr>
+          <p:cNvPr id="10" name="Text 8"/>
+          <p:cNvSpPr/>
+          <p:nvPr/>
+        </p:nvSpPr>
+        <p:spPr>
+          <a:xfrm>
+            <a:off x="1508760" y="2624328"/>
+            <a:ext cx="5486400" cy="365760"/>
           </a:xfrm>
           <a:prstGeom prst="rect">
             <a:avLst/>
@@ -7808,7 +8593,7 @@
               <a:buNone/>
             </a:pPr>
             <a:r>
-              <a:rPr lang="en-US" sz="1900" b="1" dirty="0">
+              <a:rPr lang="en-US" sz="1450" b="1" dirty="0">
                 <a:solidFill>
                   <a:srgbClr val="12324F"/>
                 </a:solidFill>
@@ -7816,22 +8601,22 @@
                 <a:ea typeface="Trebuchet MS" pitchFamily="34" charset="-122"/>
                 <a:cs typeface="Trebuchet MS" pitchFamily="34" charset="-120"/>
               </a:rPr>
-              <a:t>Indexes the tribal layer</a:t>
-            </a:r>
-            <a:endParaRPr lang="en-US" sz="1900" dirty="0"/>
-          </a:p>
-        </p:txBody>
-      </p:sp>
-      <p:sp>
-        <p:nvSpPr>
-          <p:cNvPr id="9" name="Text 7"/>
-          <p:cNvSpPr/>
-          <p:nvPr/>
-        </p:nvSpPr>
-        <p:spPr>
-          <a:xfrm>
-            <a:off x="914400" y="4114800"/>
-            <a:ext cx="3063240" cy="1554480"/>
+              <a:t>Boundary — interface ports + CSR registers</a:t>
+            </a:r>
+            <a:endParaRPr lang="en-US" sz="1450" dirty="0"/>
+          </a:p>
+        </p:txBody>
+      </p:sp>
+      <p:sp>
+        <p:nvSpPr>
+          <p:cNvPr id="11" name="Text 9"/>
+          <p:cNvSpPr/>
+          <p:nvPr/>
+        </p:nvSpPr>
+        <p:spPr>
+          <a:xfrm>
+            <a:off x="1508760" y="2971800"/>
+            <a:ext cx="5486400" cy="329184"/>
           </a:xfrm>
           <a:prstGeom prst="rect">
             <a:avLst/>
@@ -7847,7 +8632,7 @@
               <a:buNone/>
             </a:pPr>
             <a:r>
-              <a:rPr lang="en-US" sz="1400" dirty="0">
+              <a:rPr lang="en-US" sz="1200" dirty="0">
                 <a:solidFill>
                   <a:srgbClr val="5A6473"/>
                 </a:solidFill>
@@ -7855,26 +8640,65 @@
                 <a:ea typeface="Calibri" pitchFamily="34" charset="-122"/>
                 <a:cs typeface="Calibri" pitchFamily="34" charset="-120"/>
               </a:rPr>
-              <a:t>The only tool that reads the decisions in reviews and meetings — not just one static spec.</a:t>
-            </a:r>
-            <a:endParaRPr lang="en-US" sz="1400" dirty="0"/>
-          </a:p>
-        </p:txBody>
-      </p:sp>
-      <p:sp>
-        <p:nvSpPr>
-          <p:cNvPr id="10" name="Shape 8"/>
-          <p:cNvSpPr/>
-          <p:nvPr/>
-        </p:nvSpPr>
-        <p:spPr>
-          <a:xfrm>
-            <a:off x="4343400" y="2011680"/>
-            <a:ext cx="3566160" cy="3840480"/>
+              <a:t>bus 32-bit drift · STATUS missing</a:t>
+            </a:r>
+            <a:endParaRPr lang="en-US" sz="1200" dirty="0"/>
+          </a:p>
+        </p:txBody>
+      </p:sp>
+      <p:sp>
+        <p:nvSpPr>
+          <p:cNvPr id="12" name="Text 10"/>
+          <p:cNvSpPr/>
+          <p:nvPr/>
+        </p:nvSpPr>
+        <p:spPr>
+          <a:xfrm>
+            <a:off x="7086600" y="2514600"/>
+            <a:ext cx="1645920" cy="841248"/>
+          </a:xfrm>
+          <a:prstGeom prst="rect">
+            <a:avLst/>
+          </a:prstGeom>
+          <a:noFill/>
+          <a:ln/>
+        </p:spPr>
+        <p:txBody>
+          <a:bodyPr wrap="square" lIns="0" tIns="0" rIns="0" bIns="0" rtlCol="0" anchor="ctr"/>
+          <a:lstStyle/>
+          <a:p>
+            <a:pPr algn="ctr" indent="0" marL="0">
+              <a:buNone/>
+            </a:pPr>
+            <a:r>
+              <a:rPr lang="en-US" sz="1500" b="1" dirty="0">
+                <a:solidFill>
+                  <a:srgbClr val="B01722"/>
+                </a:solidFill>
+                <a:latin typeface="Trebuchet MS" pitchFamily="34" charset="0"/>
+                <a:ea typeface="Trebuchet MS" pitchFamily="34" charset="-122"/>
+                <a:cs typeface="Trebuchet MS" pitchFamily="34" charset="-120"/>
+              </a:rPr>
+              <a:t>🚨 FAIL</a:t>
+            </a:r>
+            <a:endParaRPr lang="en-US" sz="1500" dirty="0"/>
+          </a:p>
+        </p:txBody>
+      </p:sp>
+      <p:sp>
+        <p:nvSpPr>
+          <p:cNvPr id="13" name="Shape 11"/>
+          <p:cNvSpPr/>
+          <p:nvPr/>
+        </p:nvSpPr>
+        <p:spPr>
+          <a:xfrm>
+            <a:off x="640080" y="3456432"/>
+            <a:ext cx="8229600" cy="841248"/>
           </a:xfrm>
           <a:prstGeom prst="roundRect">
             <a:avLst>
-              <a:gd name="adj" fmla="val 2051"/>
+              <a:gd name="adj" fmla="val 8696"/>
             </a:avLst>
           </a:prstGeom>
           <a:solidFill>
@@ -7897,34 +8721,54 @@
       </p:sp>
       <p:sp>
         <p:nvSpPr>
-          <p:cNvPr id="11" name="Shape 9"/>
-          <p:cNvSpPr/>
-          <p:nvPr/>
-        </p:nvSpPr>
-        <p:spPr>
-          <a:xfrm>
-            <a:off x="4663440" y="2377440"/>
-            <a:ext cx="731520" cy="731520"/>
+          <p:cNvPr id="14" name="Shape 12"/>
+          <p:cNvSpPr/>
+          <p:nvPr/>
+        </p:nvSpPr>
+        <p:spPr>
+          <a:xfrm>
+            <a:off x="640080" y="3456432"/>
+            <a:ext cx="118872" cy="841248"/>
+          </a:xfrm>
+          <a:prstGeom prst="rect">
+            <a:avLst/>
+          </a:prstGeom>
+          <a:solidFill>
+            <a:srgbClr val="B01722"/>
+          </a:solidFill>
+          <a:ln/>
+        </p:spPr>
+      </p:sp>
+      <p:sp>
+        <p:nvSpPr>
+          <p:cNvPr id="15" name="Shape 13"/>
+          <p:cNvSpPr/>
+          <p:nvPr/>
+        </p:nvSpPr>
+        <p:spPr>
+          <a:xfrm>
+            <a:off x="868680" y="3639312"/>
+            <a:ext cx="475488" cy="475488"/>
           </a:xfrm>
           <a:prstGeom prst="ellipse">
             <a:avLst/>
           </a:prstGeom>
           <a:solidFill>
-            <a:srgbClr val="B8560F"/>
-          </a:solidFill>
-          <a:ln/>
-        </p:spPr>
-      </p:sp>
-      <p:sp>
-        <p:nvSpPr>
-          <p:cNvPr id="12" name="Text 10"/>
-          <p:cNvSpPr/>
-          <p:nvPr/>
-        </p:nvSpPr>
-        <p:spPr>
-          <a:xfrm>
-            <a:off x="4663440" y="2377440"/>
-            <a:ext cx="731520" cy="731520"/>
+            <a:srgbClr val="12324F"/>
+          </a:solidFill>
+          <a:ln/>
+        </p:spPr>
+      </p:sp>
+      <p:sp>
+        <p:nvSpPr>
+          <p:cNvPr id="16" name="Text 14"/>
+          <p:cNvSpPr/>
+          <p:nvPr/>
+        </p:nvSpPr>
+        <p:spPr>
+          <a:xfrm>
+            <a:off x="868680" y="3639312"/>
+            <a:ext cx="475488" cy="475488"/>
           </a:xfrm>
           <a:prstGeom prst="rect">
             <a:avLst/>
@@ -7940,7 +8784,7 @@
               <a:buNone/>
             </a:pPr>
             <a:r>
-              <a:rPr lang="en-US" sz="3000" b="1" dirty="0">
+              <a:rPr lang="en-US" sz="1400" b="1" dirty="0">
                 <a:solidFill>
                   <a:srgbClr val="FFFFFF"/>
                 </a:solidFill>
@@ -7948,22 +8792,22 @@
                 <a:ea typeface="Trebuchet MS" pitchFamily="34" charset="-122"/>
                 <a:cs typeface="Trebuchet MS" pitchFamily="34" charset="-120"/>
               </a:rPr>
-              <a:t>✓</a:t>
-            </a:r>
-            <a:endParaRPr lang="en-US" sz="3000" dirty="0"/>
-          </a:p>
-        </p:txBody>
-      </p:sp>
-      <p:sp>
-        <p:nvSpPr>
-          <p:cNvPr id="13" name="Text 11"/>
-          <p:cNvSpPr/>
-          <p:nvPr/>
-        </p:nvSpPr>
-        <p:spPr>
-          <a:xfrm>
-            <a:off x="4617720" y="3291840"/>
-            <a:ext cx="3017520" cy="822960"/>
+              <a:t>0.5</a:t>
+            </a:r>
+            <a:endParaRPr lang="en-US" sz="1400" dirty="0"/>
+          </a:p>
+        </p:txBody>
+      </p:sp>
+      <p:sp>
+        <p:nvSpPr>
+          <p:cNvPr id="17" name="Text 15"/>
+          <p:cNvSpPr/>
+          <p:nvPr/>
+        </p:nvSpPr>
+        <p:spPr>
+          <a:xfrm>
+            <a:off x="1508760" y="3566160"/>
+            <a:ext cx="5486400" cy="365760"/>
           </a:xfrm>
           <a:prstGeom prst="rect">
             <a:avLst/>
@@ -7979,7 +8823,7 @@
               <a:buNone/>
             </a:pPr>
             <a:r>
-              <a:rPr lang="en-US" sz="1900" b="1" dirty="0">
+              <a:rPr lang="en-US" sz="1450" b="1" dirty="0">
                 <a:solidFill>
                   <a:srgbClr val="12324F"/>
                 </a:solidFill>
@@ -7987,22 +8831,22 @@
                 <a:ea typeface="Trebuchet MS" pitchFamily="34" charset="-122"/>
                 <a:cs typeface="Trebuchet MS" pitchFamily="34" charset="-120"/>
               </a:rPr>
-              <a:t>Resolves source conflicts</a:t>
-            </a:r>
-            <a:endParaRPr lang="en-US" sz="1900" dirty="0"/>
-          </a:p>
-        </p:txBody>
-      </p:sp>
-      <p:sp>
-        <p:nvSpPr>
-          <p:cNvPr id="14" name="Text 12"/>
-          <p:cNvSpPr/>
-          <p:nvPr/>
-        </p:nvSpPr>
-        <p:spPr>
-          <a:xfrm>
-            <a:off x="4617720" y="4114800"/>
-            <a:ext cx="3063240" cy="1554480"/>
+              <a:t>+ Functional behavior (FSM, datapath)</a:t>
+            </a:r>
+            <a:endParaRPr lang="en-US" sz="1450" dirty="0"/>
+          </a:p>
+        </p:txBody>
+      </p:sp>
+      <p:sp>
+        <p:nvSpPr>
+          <p:cNvPr id="18" name="Text 16"/>
+          <p:cNvSpPr/>
+          <p:nvPr/>
+        </p:nvSpPr>
+        <p:spPr>
+          <a:xfrm>
+            <a:off x="1508760" y="3913632"/>
+            <a:ext cx="5486400" cy="329184"/>
           </a:xfrm>
           <a:prstGeom prst="rect">
             <a:avLst/>
@@ -8018,7 +8862,7 @@
               <a:buNone/>
             </a:pPr>
             <a:r>
-              <a:rPr lang="en-US" sz="1400" dirty="0">
+              <a:rPr lang="en-US" sz="1200" dirty="0">
                 <a:solidFill>
                   <a:srgbClr val="5A6473"/>
                 </a:solidFill>
@@ -8026,26 +8870,65 @@
                 <a:ea typeface="Calibri" pitchFamily="34" charset="-122"/>
                 <a:cs typeface="Calibri" pitchFamily="34" charset="-120"/>
               </a:rPr>
-              <a:t>Reconciles spec-vs-decision by authority + recency before ever touching the RTL.</a:t>
-            </a:r>
-            <a:endParaRPr lang="en-US" sz="1400" dirty="0"/>
-          </a:p>
-        </p:txBody>
-      </p:sp>
-      <p:sp>
-        <p:nvSpPr>
-          <p:cNvPr id="15" name="Shape 13"/>
-          <p:cNvSpPr/>
-          <p:nvPr/>
-        </p:nvSpPr>
-        <p:spPr>
-          <a:xfrm>
-            <a:off x="8046720" y="2011680"/>
-            <a:ext cx="3566160" cy="3840480"/>
+              <a:t>FSM ERROR state missing</a:t>
+            </a:r>
+            <a:endParaRPr lang="en-US" sz="1200" dirty="0"/>
+          </a:p>
+        </p:txBody>
+      </p:sp>
+      <p:sp>
+        <p:nvSpPr>
+          <p:cNvPr id="19" name="Text 17"/>
+          <p:cNvSpPr/>
+          <p:nvPr/>
+        </p:nvSpPr>
+        <p:spPr>
+          <a:xfrm>
+            <a:off x="7086600" y="3456432"/>
+            <a:ext cx="1645920" cy="841248"/>
+          </a:xfrm>
+          <a:prstGeom prst="rect">
+            <a:avLst/>
+          </a:prstGeom>
+          <a:noFill/>
+          <a:ln/>
+        </p:spPr>
+        <p:txBody>
+          <a:bodyPr wrap="square" lIns="0" tIns="0" rIns="0" bIns="0" rtlCol="0" anchor="ctr"/>
+          <a:lstStyle/>
+          <a:p>
+            <a:pPr algn="ctr" indent="0" marL="0">
+              <a:buNone/>
+            </a:pPr>
+            <a:r>
+              <a:rPr lang="en-US" sz="1500" b="1" dirty="0">
+                <a:solidFill>
+                  <a:srgbClr val="B01722"/>
+                </a:solidFill>
+                <a:latin typeface="Trebuchet MS" pitchFamily="34" charset="0"/>
+                <a:ea typeface="Trebuchet MS" pitchFamily="34" charset="-122"/>
+                <a:cs typeface="Trebuchet MS" pitchFamily="34" charset="-120"/>
+              </a:rPr>
+              <a:t>🚨 FAIL</a:t>
+            </a:r>
+            <a:endParaRPr lang="en-US" sz="1500" dirty="0"/>
+          </a:p>
+        </p:txBody>
+      </p:sp>
+      <p:sp>
+        <p:nvSpPr>
+          <p:cNvPr id="20" name="Shape 18"/>
+          <p:cNvSpPr/>
+          <p:nvPr/>
+        </p:nvSpPr>
+        <p:spPr>
+          <a:xfrm>
+            <a:off x="640080" y="4398264"/>
+            <a:ext cx="8229600" cy="841248"/>
           </a:xfrm>
           <a:prstGeom prst="roundRect">
             <a:avLst>
-              <a:gd name="adj" fmla="val 2051"/>
+              <a:gd name="adj" fmla="val 8696"/>
             </a:avLst>
           </a:prstGeom>
           <a:solidFill>
@@ -8068,34 +8951,54 @@
       </p:sp>
       <p:sp>
         <p:nvSpPr>
-          <p:cNvPr id="16" name="Shape 14"/>
-          <p:cNvSpPr/>
-          <p:nvPr/>
-        </p:nvSpPr>
-        <p:spPr>
-          <a:xfrm>
-            <a:off x="8366760" y="2377440"/>
-            <a:ext cx="731520" cy="731520"/>
+          <p:cNvPr id="21" name="Shape 19"/>
+          <p:cNvSpPr/>
+          <p:nvPr/>
+        </p:nvSpPr>
+        <p:spPr>
+          <a:xfrm>
+            <a:off x="640080" y="4398264"/>
+            <a:ext cx="118872" cy="841248"/>
+          </a:xfrm>
+          <a:prstGeom prst="rect">
+            <a:avLst/>
+          </a:prstGeom>
+          <a:solidFill>
+            <a:srgbClr val="B01722"/>
+          </a:solidFill>
+          <a:ln/>
+        </p:spPr>
+      </p:sp>
+      <p:sp>
+        <p:nvSpPr>
+          <p:cNvPr id="22" name="Shape 20"/>
+          <p:cNvSpPr/>
+          <p:nvPr/>
+        </p:nvSpPr>
+        <p:spPr>
+          <a:xfrm>
+            <a:off x="868680" y="4581144"/>
+            <a:ext cx="475488" cy="475488"/>
           </a:xfrm>
           <a:prstGeom prst="ellipse">
             <a:avLst/>
           </a:prstGeom>
           <a:solidFill>
-            <a:srgbClr val="5C2D91"/>
-          </a:solidFill>
-          <a:ln/>
-        </p:spPr>
-      </p:sp>
-      <p:sp>
-        <p:nvSpPr>
-          <p:cNvPr id="17" name="Text 15"/>
-          <p:cNvSpPr/>
-          <p:nvPr/>
-        </p:nvSpPr>
-        <p:spPr>
-          <a:xfrm>
-            <a:off x="8366760" y="2377440"/>
-            <a:ext cx="731520" cy="731520"/>
+            <a:srgbClr val="12324F"/>
+          </a:solidFill>
+          <a:ln/>
+        </p:spPr>
+      </p:sp>
+      <p:sp>
+        <p:nvSpPr>
+          <p:cNvPr id="23" name="Text 21"/>
+          <p:cNvSpPr/>
+          <p:nvPr/>
+        </p:nvSpPr>
+        <p:spPr>
+          <a:xfrm>
+            <a:off x="868680" y="4581144"/>
+            <a:ext cx="475488" cy="475488"/>
           </a:xfrm>
           <a:prstGeom prst="rect">
             <a:avLst/>
@@ -8111,7 +9014,7 @@
               <a:buNone/>
             </a:pPr>
             <a:r>
-              <a:rPr lang="en-US" sz="3000" b="1" dirty="0">
+              <a:rPr lang="en-US" sz="1400" b="1" dirty="0">
                 <a:solidFill>
                   <a:srgbClr val="FFFFFF"/>
                 </a:solidFill>
@@ -8119,22 +9022,22 @@
                 <a:ea typeface="Trebuchet MS" pitchFamily="34" charset="-122"/>
                 <a:cs typeface="Trebuchet MS" pitchFamily="34" charset="-120"/>
               </a:rPr>
-              <a:t>✓</a:t>
-            </a:r>
-            <a:endParaRPr lang="en-US" sz="3000" dirty="0"/>
-          </a:p>
-        </p:txBody>
-      </p:sp>
-      <p:sp>
-        <p:nvSpPr>
-          <p:cNvPr id="18" name="Text 16"/>
-          <p:cNvSpPr/>
-          <p:nvPr/>
-        </p:nvSpPr>
-        <p:spPr>
-          <a:xfrm>
-            <a:off x="8321040" y="3291840"/>
-            <a:ext cx="3017520" cy="822960"/>
+              <a:t>0.8</a:t>
+            </a:r>
+            <a:endParaRPr lang="en-US" sz="1400" dirty="0"/>
+          </a:p>
+        </p:txBody>
+      </p:sp>
+      <p:sp>
+        <p:nvSpPr>
+          <p:cNvPr id="24" name="Text 22"/>
+          <p:cNvSpPr/>
+          <p:nvPr/>
+        </p:nvSpPr>
+        <p:spPr>
+          <a:xfrm>
+            <a:off x="1508760" y="4507992"/>
+            <a:ext cx="5486400" cy="365760"/>
           </a:xfrm>
           <a:prstGeom prst="rect">
             <a:avLst/>
@@ -8150,7 +9053,7 @@
               <a:buNone/>
             </a:pPr>
             <a:r>
-              <a:rPr lang="en-US" sz="1900" b="1" dirty="0">
+              <a:rPr lang="en-US" sz="1450" b="1" dirty="0">
                 <a:solidFill>
                   <a:srgbClr val="12324F"/>
                 </a:solidFill>
@@ -8158,22 +9061,22 @@
                 <a:ea typeface="Trebuchet MS" pitchFamily="34" charset="-122"/>
                 <a:cs typeface="Trebuchet MS" pitchFamily="34" charset="-120"/>
               </a:rPr>
-              <a:t>Cites every finding</a:t>
-            </a:r>
-            <a:endParaRPr lang="en-US" sz="1900" dirty="0"/>
-          </a:p>
-        </p:txBody>
-      </p:sp>
-      <p:sp>
-        <p:nvSpPr>
-          <p:cNvPr id="19" name="Text 17"/>
-          <p:cNvSpPr/>
-          <p:nvPr/>
-        </p:nvSpPr>
-        <p:spPr>
-          <a:xfrm>
-            <a:off x="8321040" y="4114800"/>
-            <a:ext cx="3063240" cy="1554480"/>
+              <a:t>+ Errors, DFT, perf counters, debug</a:t>
+            </a:r>
+            <a:endParaRPr lang="en-US" sz="1450" dirty="0"/>
+          </a:p>
+        </p:txBody>
+      </p:sp>
+      <p:sp>
+        <p:nvSpPr>
+          <p:cNvPr id="25" name="Text 23"/>
+          <p:cNvSpPr/>
+          <p:nvPr/>
+        </p:nvSpPr>
+        <p:spPr>
+          <a:xfrm>
+            <a:off x="1508760" y="4855464"/>
+            <a:ext cx="5486400" cy="329184"/>
           </a:xfrm>
           <a:prstGeom prst="rect">
             <a:avLst/>
@@ -8189,7 +9092,7 @@
               <a:buNone/>
             </a:pPr>
             <a:r>
-              <a:rPr lang="en-US" sz="1400" dirty="0">
+              <a:rPr lang="en-US" sz="1200" dirty="0">
                 <a:solidFill>
                   <a:srgbClr val="5A6473"/>
                 </a:solidFill>
@@ -8197,9 +9100,445 @@
                 <a:ea typeface="Calibri" pitchFamily="34" charset="-122"/>
                 <a:cs typeface="Calibri" pitchFamily="34" charset="-120"/>
               </a:rPr>
-              <a:t>Each result links to the exact HAS/MAS clause or decision it is grounded in. No hallucinations.</a:t>
+              <a:t>scan_en missing · latency gap</a:t>
+            </a:r>
+            <a:endParaRPr lang="en-US" sz="1200" dirty="0"/>
+          </a:p>
+        </p:txBody>
+      </p:sp>
+      <p:sp>
+        <p:nvSpPr>
+          <p:cNvPr id="26" name="Text 24"/>
+          <p:cNvSpPr/>
+          <p:nvPr/>
+        </p:nvSpPr>
+        <p:spPr>
+          <a:xfrm>
+            <a:off x="7086600" y="4398264"/>
+            <a:ext cx="1645920" cy="841248"/>
+          </a:xfrm>
+          <a:prstGeom prst="rect">
+            <a:avLst/>
+          </a:prstGeom>
+          <a:noFill/>
+          <a:ln/>
+        </p:spPr>
+        <p:txBody>
+          <a:bodyPr wrap="square" lIns="0" tIns="0" rIns="0" bIns="0" rtlCol="0" anchor="ctr"/>
+          <a:lstStyle/>
+          <a:p>
+            <a:pPr algn="ctr" indent="0" marL="0">
+              <a:buNone/>
+            </a:pPr>
+            <a:r>
+              <a:rPr lang="en-US" sz="1500" b="1" dirty="0">
+                <a:solidFill>
+                  <a:srgbClr val="B01722"/>
+                </a:solidFill>
+                <a:latin typeface="Trebuchet MS" pitchFamily="34" charset="0"/>
+                <a:ea typeface="Trebuchet MS" pitchFamily="34" charset="-122"/>
+                <a:cs typeface="Trebuchet MS" pitchFamily="34" charset="-120"/>
+              </a:rPr>
+              <a:t>🚨 FAIL</a:t>
+            </a:r>
+            <a:endParaRPr lang="en-US" sz="1500" dirty="0"/>
+          </a:p>
+        </p:txBody>
+      </p:sp>
+      <p:sp>
+        <p:nvSpPr>
+          <p:cNvPr id="27" name="Shape 25"/>
+          <p:cNvSpPr/>
+          <p:nvPr/>
+        </p:nvSpPr>
+        <p:spPr>
+          <a:xfrm>
+            <a:off x="640080" y="5340096"/>
+            <a:ext cx="8229600" cy="841248"/>
+          </a:xfrm>
+          <a:prstGeom prst="roundRect">
+            <a:avLst>
+              <a:gd name="adj" fmla="val 8696"/>
+            </a:avLst>
+          </a:prstGeom>
+          <a:solidFill>
+            <a:srgbClr val="FFFFFF"/>
+          </a:solidFill>
+          <a:ln w="12700">
+            <a:solidFill>
+              <a:srgbClr val="D7E1EC"/>
+            </a:solidFill>
+            <a:prstDash val="solid"/>
+          </a:ln>
+          <a:effectLst>
+            <a:outerShdw sx="100000" sy="100000" kx="0" ky="0" algn="bl" rotWithShape="0" blurRad="101600" dist="38100" dir="5400000">
+              <a:srgbClr val="1E2733">
+                <a:alpha val="12000"/>
+              </a:srgbClr>
+            </a:outerShdw>
+          </a:effectLst>
+        </p:spPr>
+      </p:sp>
+      <p:sp>
+        <p:nvSpPr>
+          <p:cNvPr id="28" name="Shape 26"/>
+          <p:cNvSpPr/>
+          <p:nvPr/>
+        </p:nvSpPr>
+        <p:spPr>
+          <a:xfrm>
+            <a:off x="640080" y="5340096"/>
+            <a:ext cx="118872" cy="841248"/>
+          </a:xfrm>
+          <a:prstGeom prst="rect">
+            <a:avLst/>
+          </a:prstGeom>
+          <a:solidFill>
+            <a:srgbClr val="B01722"/>
+          </a:solidFill>
+          <a:ln/>
+        </p:spPr>
+      </p:sp>
+      <p:sp>
+        <p:nvSpPr>
+          <p:cNvPr id="29" name="Shape 27"/>
+          <p:cNvSpPr/>
+          <p:nvPr/>
+        </p:nvSpPr>
+        <p:spPr>
+          <a:xfrm>
+            <a:off x="868680" y="5522976"/>
+            <a:ext cx="475488" cy="475488"/>
+          </a:xfrm>
+          <a:prstGeom prst="ellipse">
+            <a:avLst/>
+          </a:prstGeom>
+          <a:solidFill>
+            <a:srgbClr val="12324F"/>
+          </a:solidFill>
+          <a:ln/>
+        </p:spPr>
+      </p:sp>
+      <p:sp>
+        <p:nvSpPr>
+          <p:cNvPr id="30" name="Text 28"/>
+          <p:cNvSpPr/>
+          <p:nvPr/>
+        </p:nvSpPr>
+        <p:spPr>
+          <a:xfrm>
+            <a:off x="868680" y="5522976"/>
+            <a:ext cx="475488" cy="475488"/>
+          </a:xfrm>
+          <a:prstGeom prst="rect">
+            <a:avLst/>
+          </a:prstGeom>
+          <a:noFill/>
+          <a:ln/>
+        </p:spPr>
+        <p:txBody>
+          <a:bodyPr wrap="square" lIns="0" tIns="0" rIns="0" bIns="0" rtlCol="0" anchor="ctr"/>
+          <a:lstStyle/>
+          <a:p>
+            <a:pPr algn="ctr" indent="0" marL="0">
+              <a:buNone/>
+            </a:pPr>
+            <a:r>
+              <a:rPr lang="en-US" sz="1400" b="1" dirty="0">
+                <a:solidFill>
+                  <a:srgbClr val="FFFFFF"/>
+                </a:solidFill>
+                <a:latin typeface="Trebuchet MS" pitchFamily="34" charset="0"/>
+                <a:ea typeface="Trebuchet MS" pitchFamily="34" charset="-122"/>
+                <a:cs typeface="Trebuchet MS" pitchFamily="34" charset="-120"/>
+              </a:rPr>
+              <a:t>1.0</a:t>
             </a:r>
             <a:endParaRPr lang="en-US" sz="1400" dirty="0"/>
+          </a:p>
+        </p:txBody>
+      </p:sp>
+      <p:sp>
+        <p:nvSpPr>
+          <p:cNvPr id="31" name="Text 29"/>
+          <p:cNvSpPr/>
+          <p:nvPr/>
+        </p:nvSpPr>
+        <p:spPr>
+          <a:xfrm>
+            <a:off x="1508760" y="5449824"/>
+            <a:ext cx="5486400" cy="365760"/>
+          </a:xfrm>
+          <a:prstGeom prst="rect">
+            <a:avLst/>
+          </a:prstGeom>
+          <a:noFill/>
+          <a:ln/>
+        </p:spPr>
+        <p:txBody>
+          <a:bodyPr wrap="square" lIns="0" tIns="0" rIns="0" bIns="0" rtlCol="0" anchor="ctr"/>
+          <a:lstStyle/>
+          <a:p>
+            <a:pPr algn="l" indent="0" marL="0">
+              <a:buNone/>
+            </a:pPr>
+            <a:r>
+              <a:rPr lang="en-US" sz="1450" b="1" dirty="0">
+                <a:solidFill>
+                  <a:srgbClr val="12324F"/>
+                </a:solidFill>
+                <a:latin typeface="Trebuchet MS" pitchFamily="34" charset="0"/>
+                <a:ea typeface="Trebuchet MS" pitchFamily="34" charset="-122"/>
+                <a:cs typeface="Trebuchet MS" pitchFamily="34" charset="-120"/>
+              </a:rPr>
+              <a:t>Overall / integration — everything</a:t>
+            </a:r>
+            <a:endParaRPr lang="en-US" sz="1450" dirty="0"/>
+          </a:p>
+        </p:txBody>
+      </p:sp>
+      <p:sp>
+        <p:nvSpPr>
+          <p:cNvPr id="32" name="Text 30"/>
+          <p:cNvSpPr/>
+          <p:nvPr/>
+        </p:nvSpPr>
+        <p:spPr>
+          <a:xfrm>
+            <a:off x="1508760" y="5797296"/>
+            <a:ext cx="5486400" cy="329184"/>
+          </a:xfrm>
+          <a:prstGeom prst="rect">
+            <a:avLst/>
+          </a:prstGeom>
+          <a:noFill/>
+          <a:ln/>
+        </p:spPr>
+        <p:txBody>
+          <a:bodyPr wrap="square" lIns="0" tIns="0" rIns="0" bIns="0" rtlCol="0" anchor="ctr"/>
+          <a:lstStyle/>
+          <a:p>
+            <a:pPr algn="l" indent="0" marL="0">
+              <a:buNone/>
+            </a:pPr>
+            <a:r>
+              <a:rPr lang="en-US" sz="1200" dirty="0">
+                <a:solidFill>
+                  <a:srgbClr val="5A6473"/>
+                </a:solidFill>
+                <a:latin typeface="Calibri" pitchFamily="34" charset="0"/>
+                <a:ea typeface="Calibri" pitchFamily="34" charset="-122"/>
+                <a:cs typeface="Calibri" pitchFamily="34" charset="-120"/>
+              </a:rPr>
+              <a:t>not yet spec-faithful</a:t>
+            </a:r>
+            <a:endParaRPr lang="en-US" sz="1200" dirty="0"/>
+          </a:p>
+        </p:txBody>
+      </p:sp>
+      <p:sp>
+        <p:nvSpPr>
+          <p:cNvPr id="33" name="Text 31"/>
+          <p:cNvSpPr/>
+          <p:nvPr/>
+        </p:nvSpPr>
+        <p:spPr>
+          <a:xfrm>
+            <a:off x="7086600" y="5340096"/>
+            <a:ext cx="1645920" cy="841248"/>
+          </a:xfrm>
+          <a:prstGeom prst="rect">
+            <a:avLst/>
+          </a:prstGeom>
+          <a:noFill/>
+          <a:ln/>
+        </p:spPr>
+        <p:txBody>
+          <a:bodyPr wrap="square" lIns="0" tIns="0" rIns="0" bIns="0" rtlCol="0" anchor="ctr"/>
+          <a:lstStyle/>
+          <a:p>
+            <a:pPr algn="ctr" indent="0" marL="0">
+              <a:buNone/>
+            </a:pPr>
+            <a:r>
+              <a:rPr lang="en-US" sz="1500" b="1" dirty="0">
+                <a:solidFill>
+                  <a:srgbClr val="B01722"/>
+                </a:solidFill>
+                <a:latin typeface="Trebuchet MS" pitchFamily="34" charset="0"/>
+                <a:ea typeface="Trebuchet MS" pitchFamily="34" charset="-122"/>
+                <a:cs typeface="Trebuchet MS" pitchFamily="34" charset="-120"/>
+              </a:rPr>
+              <a:t>🚨 FAIL</a:t>
+            </a:r>
+            <a:endParaRPr lang="en-US" sz="1500" dirty="0"/>
+          </a:p>
+        </p:txBody>
+      </p:sp>
+      <p:sp>
+        <p:nvSpPr>
+          <p:cNvPr id="34" name="Shape 32"/>
+          <p:cNvSpPr/>
+          <p:nvPr/>
+        </p:nvSpPr>
+        <p:spPr>
+          <a:xfrm>
+            <a:off x="9052560" y="2514600"/>
+            <a:ext cx="2560320" cy="3721608"/>
+          </a:xfrm>
+          <a:prstGeom prst="roundRect">
+            <a:avLst>
+              <a:gd name="adj" fmla="val 2857"/>
+            </a:avLst>
+          </a:prstGeom>
+          <a:solidFill>
+            <a:srgbClr val="12324F"/>
+          </a:solidFill>
+          <a:ln w="12700">
+            <a:solidFill>
+              <a:srgbClr val="D7E1EC"/>
+            </a:solidFill>
+            <a:prstDash val="solid"/>
+          </a:ln>
+        </p:spPr>
+      </p:sp>
+      <p:sp>
+        <p:nvSpPr>
+          <p:cNvPr id="35" name="Text 33"/>
+          <p:cNvSpPr/>
+          <p:nvPr/>
+        </p:nvSpPr>
+        <p:spPr>
+          <a:xfrm>
+            <a:off x="9052560" y="2788920"/>
+            <a:ext cx="2560320" cy="365760"/>
+          </a:xfrm>
+          <a:prstGeom prst="rect">
+            <a:avLst/>
+          </a:prstGeom>
+          <a:noFill/>
+          <a:ln/>
+        </p:spPr>
+        <p:txBody>
+          <a:bodyPr wrap="square" lIns="0" tIns="0" rIns="0" bIns="0" rtlCol="0" anchor="ctr"/>
+          <a:lstStyle/>
+          <a:p>
+            <a:pPr algn="ctr" indent="0" marL="0">
+              <a:buNone/>
+            </a:pPr>
+            <a:r>
+              <a:rPr lang="en-US" sz="1500" b="1" dirty="0">
+                <a:solidFill>
+                  <a:srgbClr val="7FD4E0"/>
+                </a:solidFill>
+                <a:latin typeface="Trebuchet MS" pitchFamily="34" charset="0"/>
+                <a:ea typeface="Trebuchet MS" pitchFamily="34" charset="-122"/>
+                <a:cs typeface="Trebuchet MS" pitchFamily="34" charset="-120"/>
+              </a:rPr>
+              <a:t>Cumulative gates</a:t>
+            </a:r>
+            <a:endParaRPr lang="en-US" sz="1500" dirty="0"/>
+          </a:p>
+        </p:txBody>
+      </p:sp>
+      <p:sp>
+        <p:nvSpPr>
+          <p:cNvPr id="36" name="Text 34"/>
+          <p:cNvSpPr/>
+          <p:nvPr/>
+        </p:nvSpPr>
+        <p:spPr>
+          <a:xfrm>
+            <a:off x="9235440" y="3246120"/>
+            <a:ext cx="2194560" cy="2011680"/>
+          </a:xfrm>
+          <a:prstGeom prst="rect">
+            <a:avLst/>
+          </a:prstGeom>
+          <a:noFill/>
+          <a:ln/>
+        </p:spPr>
+        <p:txBody>
+          <a:bodyPr wrap="square" lIns="0" tIns="0" rIns="0" bIns="0" rtlCol="0" anchor="ctr"/>
+          <a:lstStyle/>
+          <a:p>
+            <a:pPr algn="l" indent="0" marL="0">
+              <a:buNone/>
+            </a:pPr>
+            <a:r>
+              <a:rPr lang="en-US" sz="1300" dirty="0">
+                <a:solidFill>
+                  <a:srgbClr val="CADCFC"/>
+                </a:solidFill>
+                <a:latin typeface="Calibri" pitchFamily="34" charset="0"/>
+                <a:ea typeface="Calibri" pitchFamily="34" charset="-122"/>
+                <a:cs typeface="Calibri" pitchFamily="34" charset="-120"/>
+              </a:rPr>
+              <a:t>Each milestone re-checks everything below it.</a:t>
+            </a:r>
+            <a:endParaRPr lang="en-US" sz="1300" dirty="0"/>
+          </a:p>
+          <a:p>
+            <a:pPr algn="l" indent="0" marL="0">
+              <a:buNone/>
+            </a:pPr>
+            <a:endParaRPr lang="en-US" sz="1300" dirty="0"/>
+          </a:p>
+          <a:p>
+            <a:pPr algn="l" indent="0" marL="0">
+              <a:buNone/>
+            </a:pPr>
+            <a:r>
+              <a:rPr lang="en-US" sz="1300" dirty="0">
+                <a:solidFill>
+                  <a:srgbClr val="CADCFC"/>
+                </a:solidFill>
+                <a:latin typeface="Calibri" pitchFamily="34" charset="0"/>
+                <a:ea typeface="Calibri" pitchFamily="34" charset="-122"/>
+                <a:cs typeface="Calibri" pitchFamily="34" charset="-120"/>
+              </a:rPr>
+              <a:t>A gate passes only when every in-scope claim is verified — no drift, no gap.</a:t>
+            </a:r>
+            <a:endParaRPr lang="en-US" sz="1300" dirty="0"/>
+          </a:p>
+        </p:txBody>
+      </p:sp>
+      <p:sp>
+        <p:nvSpPr>
+          <p:cNvPr id="37" name="Text 35"/>
+          <p:cNvSpPr/>
+          <p:nvPr/>
+        </p:nvSpPr>
+        <p:spPr>
+          <a:xfrm>
+            <a:off x="9052560" y="5669280"/>
+            <a:ext cx="2560320" cy="457200"/>
+          </a:xfrm>
+          <a:prstGeom prst="rect">
+            <a:avLst/>
+          </a:prstGeom>
+          <a:noFill/>
+          <a:ln/>
+        </p:spPr>
+        <p:txBody>
+          <a:bodyPr wrap="square" lIns="0" tIns="0" rIns="0" bIns="0" rtlCol="0" anchor="ctr"/>
+          <a:lstStyle/>
+          <a:p>
+            <a:pPr algn="ctr" indent="0" marL="0">
+              <a:buNone/>
+            </a:pPr>
+            <a:r>
+              <a:rPr lang="en-US" sz="1250" b="1" i="1" dirty="0">
+                <a:solidFill>
+                  <a:srgbClr val="FFFFFF"/>
+                </a:solidFill>
+                <a:latin typeface="Trebuchet MS" pitchFamily="34" charset="0"/>
+                <a:ea typeface="Trebuchet MS" pitchFamily="34" charset="-122"/>
+                <a:cs typeface="Trebuchet MS" pitchFamily="34" charset="-120"/>
+              </a:rPr>
+              <a:t>RTL isn't even 0.1-ready yet.</a:t>
+            </a:r>
+            <a:endParaRPr lang="en-US" sz="1250" dirty="0"/>
           </a:p>
         </p:txBody>
       </p:sp>
@@ -8288,7 +9627,7 @@
                 <a:ea typeface="Trebuchet MS" pitchFamily="34" charset="-122"/>
                 <a:cs typeface="Trebuchet MS" pitchFamily="34" charset="-120"/>
               </a:rPr>
-              <a:t>IMPACT</a:t>
+              <a:t>WHY IT'S DIFFERENT</a:t>
             </a:r>
             <a:endParaRPr lang="en-US" sz="1300" dirty="0"/>
           </a:p>
@@ -8327,7 +9666,7 @@
                 <a:ea typeface="Trebuchet MS" pitchFamily="34" charset="-122"/>
                 <a:cs typeface="Trebuchet MS" pitchFamily="34" charset="-120"/>
               </a:rPr>
-              <a:t>From hours of review to seconds</a:t>
+              <a:t>Grounded. Traceable. Trustworthy.</a:t>
             </a:r>
             <a:endParaRPr lang="en-US" sz="3000" dirty="0"/>
           </a:p>
@@ -8341,12 +9680,12 @@
         </p:nvSpPr>
         <p:spPr>
           <a:xfrm>
-            <a:off x="640080" y="1920240"/>
-            <a:ext cx="3566160" cy="1737360"/>
+            <a:off x="640080" y="2011680"/>
+            <a:ext cx="3566160" cy="3840480"/>
           </a:xfrm>
           <a:prstGeom prst="roundRect">
             <a:avLst>
-              <a:gd name="adj" fmla="val 4211"/>
+              <a:gd name="adj" fmla="val 2051"/>
             </a:avLst>
           </a:prstGeom>
           <a:solidFill>
@@ -8369,53 +9708,73 @@
       </p:sp>
       <p:sp>
         <p:nvSpPr>
-          <p:cNvPr id="6" name="Text 4"/>
-          <p:cNvSpPr/>
-          <p:nvPr/>
-        </p:nvSpPr>
-        <p:spPr>
-          <a:xfrm>
-            <a:off x="914400" y="2148840"/>
-            <a:ext cx="3017520" cy="868680"/>
-          </a:xfrm>
-          <a:prstGeom prst="rect">
-            <a:avLst/>
-          </a:prstGeom>
-          <a:noFill/>
-          <a:ln/>
-        </p:spPr>
-        <p:txBody>
-          <a:bodyPr wrap="square" lIns="0" tIns="0" rIns="0" bIns="0" rtlCol="0" anchor="ctr"/>
-          <a:lstStyle/>
-          <a:p>
-            <a:pPr algn="l" indent="0" marL="0">
-              <a:buNone/>
-            </a:pPr>
-            <a:r>
-              <a:rPr lang="en-US" sz="4000" b="1" dirty="0">
-                <a:solidFill>
-                  <a:srgbClr val="0C8599"/>
+          <p:cNvPr id="6" name="Shape 4"/>
+          <p:cNvSpPr/>
+          <p:nvPr/>
+        </p:nvSpPr>
+        <p:spPr>
+          <a:xfrm>
+            <a:off x="960120" y="2377440"/>
+            <a:ext cx="731520" cy="731520"/>
+          </a:xfrm>
+          <a:prstGeom prst="ellipse">
+            <a:avLst/>
+          </a:prstGeom>
+          <a:solidFill>
+            <a:srgbClr val="0C8599"/>
+          </a:solidFill>
+          <a:ln/>
+        </p:spPr>
+      </p:sp>
+      <p:sp>
+        <p:nvSpPr>
+          <p:cNvPr id="7" name="Text 5"/>
+          <p:cNvSpPr/>
+          <p:nvPr/>
+        </p:nvSpPr>
+        <p:spPr>
+          <a:xfrm>
+            <a:off x="960120" y="2377440"/>
+            <a:ext cx="731520" cy="731520"/>
+          </a:xfrm>
+          <a:prstGeom prst="rect">
+            <a:avLst/>
+          </a:prstGeom>
+          <a:noFill/>
+          <a:ln/>
+        </p:spPr>
+        <p:txBody>
+          <a:bodyPr wrap="square" lIns="0" tIns="0" rIns="0" bIns="0" rtlCol="0" anchor="ctr"/>
+          <a:lstStyle/>
+          <a:p>
+            <a:pPr algn="ctr" indent="0" marL="0">
+              <a:buNone/>
+            </a:pPr>
+            <a:r>
+              <a:rPr lang="en-US" sz="3000" b="1" dirty="0">
+                <a:solidFill>
+                  <a:srgbClr val="FFFFFF"/>
                 </a:solidFill>
                 <a:latin typeface="Trebuchet MS" pitchFamily="34" charset="0"/>
                 <a:ea typeface="Trebuchet MS" pitchFamily="34" charset="-122"/>
                 <a:cs typeface="Trebuchet MS" pitchFamily="34" charset="-120"/>
               </a:rPr>
-              <a:t>seconds</a:t>
-            </a:r>
-            <a:endParaRPr lang="en-US" sz="4000" dirty="0"/>
-          </a:p>
-        </p:txBody>
-      </p:sp>
-      <p:sp>
-        <p:nvSpPr>
-          <p:cNvPr id="7" name="Text 5"/>
-          <p:cNvSpPr/>
-          <p:nvPr/>
-        </p:nvSpPr>
-        <p:spPr>
-          <a:xfrm>
-            <a:off x="932688" y="3063240"/>
-            <a:ext cx="3108960" cy="502920"/>
+              <a:t>✓</a:t>
+            </a:r>
+            <a:endParaRPr lang="en-US" sz="3000" dirty="0"/>
+          </a:p>
+        </p:txBody>
+      </p:sp>
+      <p:sp>
+        <p:nvSpPr>
+          <p:cNvPr id="8" name="Text 6"/>
+          <p:cNvSpPr/>
+          <p:nvPr/>
+        </p:nvSpPr>
+        <p:spPr>
+          <a:xfrm>
+            <a:off x="914400" y="3291840"/>
+            <a:ext cx="3017520" cy="822960"/>
           </a:xfrm>
           <a:prstGeom prst="rect">
             <a:avLst/>
@@ -8431,7 +9790,46 @@
               <a:buNone/>
             </a:pPr>
             <a:r>
-              <a:rPr lang="en-US" sz="1350" dirty="0">
+              <a:rPr lang="en-US" sz="1900" b="1" dirty="0">
+                <a:solidFill>
+                  <a:srgbClr val="12324F"/>
+                </a:solidFill>
+                <a:latin typeface="Trebuchet MS" pitchFamily="34" charset="0"/>
+                <a:ea typeface="Trebuchet MS" pitchFamily="34" charset="-122"/>
+                <a:cs typeface="Trebuchet MS" pitchFamily="34" charset="-120"/>
+              </a:rPr>
+              <a:t>Indexes the tribal layer</a:t>
+            </a:r>
+            <a:endParaRPr lang="en-US" sz="1900" dirty="0"/>
+          </a:p>
+        </p:txBody>
+      </p:sp>
+      <p:sp>
+        <p:nvSpPr>
+          <p:cNvPr id="9" name="Text 7"/>
+          <p:cNvSpPr/>
+          <p:nvPr/>
+        </p:nvSpPr>
+        <p:spPr>
+          <a:xfrm>
+            <a:off x="914400" y="4114800"/>
+            <a:ext cx="3063240" cy="1554480"/>
+          </a:xfrm>
+          <a:prstGeom prst="rect">
+            <a:avLst/>
+          </a:prstGeom>
+          <a:noFill/>
+          <a:ln/>
+        </p:spPr>
+        <p:txBody>
+          <a:bodyPr wrap="square" lIns="0" tIns="0" rIns="0" bIns="0" rtlCol="0" anchor="ctr"/>
+          <a:lstStyle/>
+          <a:p>
+            <a:pPr algn="l" indent="0" marL="0">
+              <a:buNone/>
+            </a:pPr>
+            <a:r>
+              <a:rPr lang="en-US" sz="1400" dirty="0">
                 <a:solidFill>
                   <a:srgbClr val="5A6473"/>
                 </a:solidFill>
@@ -8439,26 +9837,26 @@
                 <a:ea typeface="Calibri" pitchFamily="34" charset="-122"/>
                 <a:cs typeface="Calibri" pitchFamily="34" charset="-120"/>
               </a:rPr>
-              <a:t>to audit RTL against 4 intent layers</a:t>
-            </a:r>
-            <a:endParaRPr lang="en-US" sz="1350" dirty="0"/>
-          </a:p>
-        </p:txBody>
-      </p:sp>
-      <p:sp>
-        <p:nvSpPr>
-          <p:cNvPr id="8" name="Shape 6"/>
-          <p:cNvSpPr/>
-          <p:nvPr/>
-        </p:nvSpPr>
-        <p:spPr>
-          <a:xfrm>
-            <a:off x="4343400" y="1920240"/>
-            <a:ext cx="3566160" cy="1737360"/>
+              <a:t>The only tool that reads the decisions in reviews and meetings — not just one static spec.</a:t>
+            </a:r>
+            <a:endParaRPr lang="en-US" sz="1400" dirty="0"/>
+          </a:p>
+        </p:txBody>
+      </p:sp>
+      <p:sp>
+        <p:nvSpPr>
+          <p:cNvPr id="10" name="Shape 8"/>
+          <p:cNvSpPr/>
+          <p:nvPr/>
+        </p:nvSpPr>
+        <p:spPr>
+          <a:xfrm>
+            <a:off x="4343400" y="2011680"/>
+            <a:ext cx="3566160" cy="3840480"/>
           </a:xfrm>
           <a:prstGeom prst="roundRect">
             <a:avLst>
-              <a:gd name="adj" fmla="val 4211"/>
+              <a:gd name="adj" fmla="val 2051"/>
             </a:avLst>
           </a:prstGeom>
           <a:solidFill>
@@ -8481,53 +9879,73 @@
       </p:sp>
       <p:sp>
         <p:nvSpPr>
-          <p:cNvPr id="9" name="Text 7"/>
-          <p:cNvSpPr/>
-          <p:nvPr/>
-        </p:nvSpPr>
-        <p:spPr>
-          <a:xfrm>
-            <a:off x="4617720" y="2148840"/>
-            <a:ext cx="3017520" cy="868680"/>
-          </a:xfrm>
-          <a:prstGeom prst="rect">
-            <a:avLst/>
-          </a:prstGeom>
-          <a:noFill/>
-          <a:ln/>
-        </p:spPr>
-        <p:txBody>
-          <a:bodyPr wrap="square" lIns="0" tIns="0" rIns="0" bIns="0" rtlCol="0" anchor="ctr"/>
-          <a:lstStyle/>
-          <a:p>
-            <a:pPr algn="l" indent="0" marL="0">
-              <a:buNone/>
-            </a:pPr>
-            <a:r>
-              <a:rPr lang="en-US" sz="4000" b="1" dirty="0">
-                <a:solidFill>
-                  <a:srgbClr val="12324F"/>
+          <p:cNvPr id="11" name="Shape 9"/>
+          <p:cNvSpPr/>
+          <p:nvPr/>
+        </p:nvSpPr>
+        <p:spPr>
+          <a:xfrm>
+            <a:off x="4663440" y="2377440"/>
+            <a:ext cx="731520" cy="731520"/>
+          </a:xfrm>
+          <a:prstGeom prst="ellipse">
+            <a:avLst/>
+          </a:prstGeom>
+          <a:solidFill>
+            <a:srgbClr val="B8560F"/>
+          </a:solidFill>
+          <a:ln/>
+        </p:spPr>
+      </p:sp>
+      <p:sp>
+        <p:nvSpPr>
+          <p:cNvPr id="12" name="Text 10"/>
+          <p:cNvSpPr/>
+          <p:nvPr/>
+        </p:nvSpPr>
+        <p:spPr>
+          <a:xfrm>
+            <a:off x="4663440" y="2377440"/>
+            <a:ext cx="731520" cy="731520"/>
+          </a:xfrm>
+          <a:prstGeom prst="rect">
+            <a:avLst/>
+          </a:prstGeom>
+          <a:noFill/>
+          <a:ln/>
+        </p:spPr>
+        <p:txBody>
+          <a:bodyPr wrap="square" lIns="0" tIns="0" rIns="0" bIns="0" rtlCol="0" anchor="ctr"/>
+          <a:lstStyle/>
+          <a:p>
+            <a:pPr algn="ctr" indent="0" marL="0">
+              <a:buNone/>
+            </a:pPr>
+            <a:r>
+              <a:rPr lang="en-US" sz="3000" b="1" dirty="0">
+                <a:solidFill>
+                  <a:srgbClr val="FFFFFF"/>
                 </a:solidFill>
                 <a:latin typeface="Trebuchet MS" pitchFamily="34" charset="0"/>
                 <a:ea typeface="Trebuchet MS" pitchFamily="34" charset="-122"/>
                 <a:cs typeface="Trebuchet MS" pitchFamily="34" charset="-120"/>
               </a:rPr>
-              <a:t>100%</a:t>
-            </a:r>
-            <a:endParaRPr lang="en-US" sz="4000" dirty="0"/>
-          </a:p>
-        </p:txBody>
-      </p:sp>
-      <p:sp>
-        <p:nvSpPr>
-          <p:cNvPr id="10" name="Text 8"/>
-          <p:cNvSpPr/>
-          <p:nvPr/>
-        </p:nvSpPr>
-        <p:spPr>
-          <a:xfrm>
-            <a:off x="4636008" y="3063240"/>
-            <a:ext cx="3108960" cy="502920"/>
+              <a:t>✓</a:t>
+            </a:r>
+            <a:endParaRPr lang="en-US" sz="3000" dirty="0"/>
+          </a:p>
+        </p:txBody>
+      </p:sp>
+      <p:sp>
+        <p:nvSpPr>
+          <p:cNvPr id="13" name="Text 11"/>
+          <p:cNvSpPr/>
+          <p:nvPr/>
+        </p:nvSpPr>
+        <p:spPr>
+          <a:xfrm>
+            <a:off x="4617720" y="3291840"/>
+            <a:ext cx="3017520" cy="822960"/>
           </a:xfrm>
           <a:prstGeom prst="rect">
             <a:avLst/>
@@ -8543,7 +9961,46 @@
               <a:buNone/>
             </a:pPr>
             <a:r>
-              <a:rPr lang="en-US" sz="1350" dirty="0">
+              <a:rPr lang="en-US" sz="1900" b="1" dirty="0">
+                <a:solidFill>
+                  <a:srgbClr val="12324F"/>
+                </a:solidFill>
+                <a:latin typeface="Trebuchet MS" pitchFamily="34" charset="0"/>
+                <a:ea typeface="Trebuchet MS" pitchFamily="34" charset="-122"/>
+                <a:cs typeface="Trebuchet MS" pitchFamily="34" charset="-120"/>
+              </a:rPr>
+              <a:t>Resolves source conflicts</a:t>
+            </a:r>
+            <a:endParaRPr lang="en-US" sz="1900" dirty="0"/>
+          </a:p>
+        </p:txBody>
+      </p:sp>
+      <p:sp>
+        <p:nvSpPr>
+          <p:cNvPr id="14" name="Text 12"/>
+          <p:cNvSpPr/>
+          <p:nvPr/>
+        </p:nvSpPr>
+        <p:spPr>
+          <a:xfrm>
+            <a:off x="4617720" y="4114800"/>
+            <a:ext cx="3063240" cy="1554480"/>
+          </a:xfrm>
+          <a:prstGeom prst="rect">
+            <a:avLst/>
+          </a:prstGeom>
+          <a:noFill/>
+          <a:ln/>
+        </p:spPr>
+        <p:txBody>
+          <a:bodyPr wrap="square" lIns="0" tIns="0" rIns="0" bIns="0" rtlCol="0" anchor="ctr"/>
+          <a:lstStyle/>
+          <a:p>
+            <a:pPr algn="l" indent="0" marL="0">
+              <a:buNone/>
+            </a:pPr>
+            <a:r>
+              <a:rPr lang="en-US" sz="1400" dirty="0">
                 <a:solidFill>
                   <a:srgbClr val="5A6473"/>
                 </a:solidFill>
@@ -8551,26 +10008,26 @@
                 <a:ea typeface="Calibri" pitchFamily="34" charset="-122"/>
                 <a:cs typeface="Calibri" pitchFamily="34" charset="-120"/>
               </a:rPr>
-              <a:t>of findings source-cited</a:t>
-            </a:r>
-            <a:endParaRPr lang="en-US" sz="1350" dirty="0"/>
-          </a:p>
-        </p:txBody>
-      </p:sp>
-      <p:sp>
-        <p:nvSpPr>
-          <p:cNvPr id="11" name="Shape 9"/>
-          <p:cNvSpPr/>
-          <p:nvPr/>
-        </p:nvSpPr>
-        <p:spPr>
-          <a:xfrm>
-            <a:off x="8046720" y="1920240"/>
-            <a:ext cx="3566160" cy="1737360"/>
+              <a:t>Reconciles spec-vs-decision by authority + recency before ever touching the RTL.</a:t>
+            </a:r>
+            <a:endParaRPr lang="en-US" sz="1400" dirty="0"/>
+          </a:p>
+        </p:txBody>
+      </p:sp>
+      <p:sp>
+        <p:nvSpPr>
+          <p:cNvPr id="15" name="Shape 13"/>
+          <p:cNvSpPr/>
+          <p:nvPr/>
+        </p:nvSpPr>
+        <p:spPr>
+          <a:xfrm>
+            <a:off x="8046720" y="2011680"/>
+            <a:ext cx="3566160" cy="3840480"/>
           </a:xfrm>
           <a:prstGeom prst="roundRect">
             <a:avLst>
-              <a:gd name="adj" fmla="val 4211"/>
+              <a:gd name="adj" fmla="val 2051"/>
             </a:avLst>
           </a:prstGeom>
           <a:solidFill>
@@ -8593,53 +10050,73 @@
       </p:sp>
       <p:sp>
         <p:nvSpPr>
-          <p:cNvPr id="12" name="Text 10"/>
-          <p:cNvSpPr/>
-          <p:nvPr/>
-        </p:nvSpPr>
-        <p:spPr>
-          <a:xfrm>
-            <a:off x="8321040" y="2148840"/>
-            <a:ext cx="3017520" cy="868680"/>
-          </a:xfrm>
-          <a:prstGeom prst="rect">
-            <a:avLst/>
-          </a:prstGeom>
-          <a:noFill/>
-          <a:ln/>
-        </p:spPr>
-        <p:txBody>
-          <a:bodyPr wrap="square" lIns="0" tIns="0" rIns="0" bIns="0" rtlCol="0" anchor="ctr"/>
-          <a:lstStyle/>
-          <a:p>
-            <a:pPr algn="l" indent="0" marL="0">
-              <a:buNone/>
-            </a:pPr>
-            <a:r>
-              <a:rPr lang="en-US" sz="4000" b="1" dirty="0">
-                <a:solidFill>
-                  <a:srgbClr val="0C6B78"/>
+          <p:cNvPr id="16" name="Shape 14"/>
+          <p:cNvSpPr/>
+          <p:nvPr/>
+        </p:nvSpPr>
+        <p:spPr>
+          <a:xfrm>
+            <a:off x="8366760" y="2377440"/>
+            <a:ext cx="731520" cy="731520"/>
+          </a:xfrm>
+          <a:prstGeom prst="ellipse">
+            <a:avLst/>
+          </a:prstGeom>
+          <a:solidFill>
+            <a:srgbClr val="5C2D91"/>
+          </a:solidFill>
+          <a:ln/>
+        </p:spPr>
+      </p:sp>
+      <p:sp>
+        <p:nvSpPr>
+          <p:cNvPr id="17" name="Text 15"/>
+          <p:cNvSpPr/>
+          <p:nvPr/>
+        </p:nvSpPr>
+        <p:spPr>
+          <a:xfrm>
+            <a:off x="8366760" y="2377440"/>
+            <a:ext cx="731520" cy="731520"/>
+          </a:xfrm>
+          <a:prstGeom prst="rect">
+            <a:avLst/>
+          </a:prstGeom>
+          <a:noFill/>
+          <a:ln/>
+        </p:spPr>
+        <p:txBody>
+          <a:bodyPr wrap="square" lIns="0" tIns="0" rIns="0" bIns="0" rtlCol="0" anchor="ctr"/>
+          <a:lstStyle/>
+          <a:p>
+            <a:pPr algn="ctr" indent="0" marL="0">
+              <a:buNone/>
+            </a:pPr>
+            <a:r>
+              <a:rPr lang="en-US" sz="3000" b="1" dirty="0">
+                <a:solidFill>
+                  <a:srgbClr val="FFFFFF"/>
                 </a:solidFill>
                 <a:latin typeface="Trebuchet MS" pitchFamily="34" charset="0"/>
                 <a:ea typeface="Trebuchet MS" pitchFamily="34" charset="-122"/>
                 <a:cs typeface="Trebuchet MS" pitchFamily="34" charset="-120"/>
               </a:rPr>
-              <a:t>0</a:t>
-            </a:r>
-            <a:endParaRPr lang="en-US" sz="4000" dirty="0"/>
-          </a:p>
-        </p:txBody>
-      </p:sp>
-      <p:sp>
-        <p:nvSpPr>
-          <p:cNvPr id="13" name="Text 11"/>
-          <p:cNvSpPr/>
-          <p:nvPr/>
-        </p:nvSpPr>
-        <p:spPr>
-          <a:xfrm>
-            <a:off x="8339328" y="3063240"/>
-            <a:ext cx="3108960" cy="502920"/>
+              <a:t>✓</a:t>
+            </a:r>
+            <a:endParaRPr lang="en-US" sz="3000" dirty="0"/>
+          </a:p>
+        </p:txBody>
+      </p:sp>
+      <p:sp>
+        <p:nvSpPr>
+          <p:cNvPr id="18" name="Text 16"/>
+          <p:cNvSpPr/>
+          <p:nvPr/>
+        </p:nvSpPr>
+        <p:spPr>
+          <a:xfrm>
+            <a:off x="8321040" y="3291840"/>
+            <a:ext cx="3017520" cy="822960"/>
           </a:xfrm>
           <a:prstGeom prst="rect">
             <a:avLst/>
@@ -8655,7 +10132,46 @@
               <a:buNone/>
             </a:pPr>
             <a:r>
-              <a:rPr lang="en-US" sz="1350" dirty="0">
+              <a:rPr lang="en-US" sz="1900" b="1" dirty="0">
+                <a:solidFill>
+                  <a:srgbClr val="12324F"/>
+                </a:solidFill>
+                <a:latin typeface="Trebuchet MS" pitchFamily="34" charset="0"/>
+                <a:ea typeface="Trebuchet MS" pitchFamily="34" charset="-122"/>
+                <a:cs typeface="Trebuchet MS" pitchFamily="34" charset="-120"/>
+              </a:rPr>
+              <a:t>Cites every finding</a:t>
+            </a:r>
+            <a:endParaRPr lang="en-US" sz="1900" dirty="0"/>
+          </a:p>
+        </p:txBody>
+      </p:sp>
+      <p:sp>
+        <p:nvSpPr>
+          <p:cNvPr id="19" name="Text 17"/>
+          <p:cNvSpPr/>
+          <p:nvPr/>
+        </p:nvSpPr>
+        <p:spPr>
+          <a:xfrm>
+            <a:off x="8321040" y="4114800"/>
+            <a:ext cx="3063240" cy="1554480"/>
+          </a:xfrm>
+          <a:prstGeom prst="rect">
+            <a:avLst/>
+          </a:prstGeom>
+          <a:noFill/>
+          <a:ln/>
+        </p:spPr>
+        <p:txBody>
+          <a:bodyPr wrap="square" lIns="0" tIns="0" rIns="0" bIns="0" rtlCol="0" anchor="ctr"/>
+          <a:lstStyle/>
+          <a:p>
+            <a:pPr algn="l" indent="0" marL="0">
+              <a:buNone/>
+            </a:pPr>
+            <a:r>
+              <a:rPr lang="en-US" sz="1400" dirty="0">
                 <a:solidFill>
                   <a:srgbClr val="5A6473"/>
                 </a:solidFill>
@@ -8663,166 +10179,9 @@
                 <a:ea typeface="Calibri" pitchFamily="34" charset="-122"/>
                 <a:cs typeface="Calibri" pitchFamily="34" charset="-120"/>
               </a:rPr>
-              <a:t>API keys — runs fully offline</a:t>
-            </a:r>
-            <a:endParaRPr lang="en-US" sz="1350" dirty="0"/>
-          </a:p>
-        </p:txBody>
-      </p:sp>
-      <p:sp>
-        <p:nvSpPr>
-          <p:cNvPr id="14" name="Text 12"/>
-          <p:cNvSpPr/>
-          <p:nvPr/>
-        </p:nvSpPr>
-        <p:spPr>
-          <a:xfrm>
-            <a:off x="640080" y="3977640"/>
-            <a:ext cx="5486400" cy="457200"/>
-          </a:xfrm>
-          <a:prstGeom prst="rect">
-            <a:avLst/>
-          </a:prstGeom>
-          <a:noFill/>
-          <a:ln/>
-        </p:spPr>
-        <p:txBody>
-          <a:bodyPr wrap="square" lIns="0" tIns="0" rIns="0" bIns="0" rtlCol="0" anchor="ctr"/>
-          <a:lstStyle/>
-          <a:p>
-            <a:pPr indent="0" marL="0">
-              <a:buNone/>
-            </a:pPr>
-            <a:r>
-              <a:rPr lang="en-US" sz="1800" b="1" dirty="0">
-                <a:solidFill>
-                  <a:srgbClr val="12324F"/>
-                </a:solidFill>
-                <a:latin typeface="Trebuchet MS" pitchFamily="34" charset="0"/>
-                <a:ea typeface="Trebuchet MS" pitchFamily="34" charset="-122"/>
-                <a:cs typeface="Trebuchet MS" pitchFamily="34" charset="-120"/>
-              </a:rPr>
-              <a:t>Who benefits</a:t>
-            </a:r>
-            <a:endParaRPr lang="en-US" sz="1800" dirty="0"/>
-          </a:p>
-        </p:txBody>
-      </p:sp>
-      <p:sp>
-        <p:nvSpPr>
-          <p:cNvPr id="15" name="Text 13"/>
-          <p:cNvSpPr/>
-          <p:nvPr/>
-        </p:nvSpPr>
-        <p:spPr>
-          <a:xfrm>
-            <a:off x="640080" y="4480560"/>
-            <a:ext cx="10881360" cy="2011680"/>
-          </a:xfrm>
-          <a:prstGeom prst="rect">
-            <a:avLst/>
-          </a:prstGeom>
-          <a:noFill/>
-          <a:ln/>
-        </p:spPr>
-        <p:txBody>
-          <a:bodyPr wrap="square" rtlCol="0" anchor="ctr"/>
-          <a:lstStyle/>
-          <a:p>
-            <a:pPr marL="342900" indent="-342900">
-              <a:lnSpc>
-                <a:spcPct val="115000"/>
-              </a:lnSpc>
-              <a:spcAft>
-                <a:spcPts val="800"/>
-              </a:spcAft>
-              <a:buSzPct val="100000"/>
-              <a:buChar char="•"/>
-            </a:pPr>
-            <a:r>
-              <a:rPr lang="en-US" sz="1600" dirty="0">
-                <a:solidFill>
-                  <a:srgbClr val="1E2733"/>
-                </a:solidFill>
-                <a:latin typeface="Calibri" pitchFamily="34" charset="0"/>
-                <a:ea typeface="Calibri" pitchFamily="34" charset="-122"/>
-                <a:cs typeface="Calibri" pitchFamily="34" charset="-120"/>
-              </a:rPr>
-              <a:t>Design &amp; verification engineers — stop hand-diffing specs against RTL</a:t>
-            </a:r>
-            <a:endParaRPr lang="en-US" sz="1600" dirty="0"/>
-          </a:p>
-          <a:p>
-            <a:pPr marL="342900" indent="-342900">
-              <a:lnSpc>
-                <a:spcPct val="115000"/>
-              </a:lnSpc>
-              <a:spcAft>
-                <a:spcPts val="800"/>
-              </a:spcAft>
-              <a:buSzPct val="100000"/>
-              <a:buChar char="•"/>
-            </a:pPr>
-            <a:r>
-              <a:rPr lang="en-US" sz="1600" dirty="0">
-                <a:solidFill>
-                  <a:srgbClr val="1E2733"/>
-                </a:solidFill>
-                <a:latin typeface="Calibri" pitchFamily="34" charset="0"/>
-                <a:ea typeface="Calibri" pitchFamily="34" charset="-122"/>
-                <a:cs typeface="Calibri" pitchFamily="34" charset="-120"/>
-              </a:rPr>
-              <a:t>Architects — see which top-level requirements are actually implemented</a:t>
-            </a:r>
-            <a:endParaRPr lang="en-US" sz="1600" dirty="0"/>
-          </a:p>
-          <a:p>
-            <a:pPr marL="342900" indent="-342900">
-              <a:lnSpc>
-                <a:spcPct val="115000"/>
-              </a:lnSpc>
-              <a:spcAft>
-                <a:spcPts val="800"/>
-              </a:spcAft>
-              <a:buSzPct val="100000"/>
-              <a:buChar char="•"/>
-            </a:pPr>
-            <a:r>
-              <a:rPr lang="en-US" sz="1600" dirty="0">
-                <a:solidFill>
-                  <a:srgbClr val="1E2733"/>
-                </a:solidFill>
-                <a:latin typeface="Calibri" pitchFamily="34" charset="0"/>
-                <a:ea typeface="Calibri" pitchFamily="34" charset="-122"/>
-                <a:cs typeface="Calibri" pitchFamily="34" charset="-120"/>
-              </a:rPr>
-              <a:t>Leads &amp; PMs — a living drift metric per commit, not a one-time review</a:t>
-            </a:r>
-            <a:endParaRPr lang="en-US" sz="1600" dirty="0"/>
-          </a:p>
-          <a:p>
-            <a:pPr marL="342900" indent="-342900">
-              <a:lnSpc>
-                <a:spcPct val="115000"/>
-              </a:lnSpc>
-              <a:spcAft>
-                <a:spcPts val="800"/>
-              </a:spcAft>
-              <a:buSzPct val="100000"/>
-              <a:buChar char="•"/>
-            </a:pPr>
-            <a:r>
-              <a:rPr lang="en-US" sz="1600" dirty="0">
-                <a:solidFill>
-                  <a:srgbClr val="1E2733"/>
-                </a:solidFill>
-                <a:latin typeface="Calibri" pitchFamily="34" charset="0"/>
-                <a:ea typeface="Calibri" pitchFamily="34" charset="-122"/>
-                <a:cs typeface="Calibri" pitchFamily="34" charset="-120"/>
-              </a:rPr>
-              <a:t>Security IP teams — catch key/register drift before tapeout</a:t>
-            </a:r>
-            <a:endParaRPr lang="en-US" sz="1600" dirty="0"/>
+              <a:t>Each result links to the exact HAS/MAS clause or decision it is grounded in. No hallucinations.</a:t>
+            </a:r>
+            <a:endParaRPr lang="en-US" sz="1400" dirty="0"/>
           </a:p>
         </p:txBody>
       </p:sp>

</xml_diff>

<commit_message>
Rename subtitle: Design Intent Ledger -> Design Intent Auditor
Rename across the repo (README, source docstrings, report headers, deck,
diagram, narration) and regenerate the architecture PNG, deck, and report
samples/screenshot. Also update residual lowercase 'ledger' concept wording
to 'report'/'audit'.

Co-authored-by: Copilot <223556219+Copilot@users.noreply.github.com>
</commit_message>
<xml_diff>
--- a/presentation/Spec-RTL-Sentinel-Pitch.pptx
+++ b/presentation/Spec-RTL-Sentinel-Pitch.pptx
@@ -1857,7 +1857,7 @@
                 <a:ea typeface="Trebuchet MS" pitchFamily="34" charset="-122"/>
                 <a:cs typeface="Trebuchet MS" pitchFamily="34" charset="-120"/>
               </a:rPr>
-              <a:t>Design Intent Ledger</a:t>
+              <a:t>Design Intent Auditor</a:t>
             </a:r>
             <a:endParaRPr lang="en-US" sz="2700" dirty="0"/>
           </a:p>
@@ -4973,7 +4973,7 @@
                 <a:ea typeface="Trebuchet MS" pitchFamily="34" charset="-122"/>
                 <a:cs typeface="Trebuchet MS" pitchFamily="34" charset="-120"/>
               </a:rPr>
-              <a:t>One ledger across every layer of intent</a:t>
+              <a:t>One audit across every layer of intent</a:t>
             </a:r>
             <a:endParaRPr lang="en-US" sz="3000" dirty="0"/>
           </a:p>
@@ -7167,7 +7167,7 @@
                 <a:ea typeface="Calibri" pitchFamily="34" charset="-122"/>
                 <a:cs typeface="Calibri" pitchFamily="34" charset="-120"/>
               </a:rPr>
-              <a:t>Layered drift ledger</a:t>
+              <a:t>Layered drift report</a:t>
             </a:r>
             <a:endParaRPr lang="en-US" sz="1300" dirty="0"/>
           </a:p>

</xml_diff>

<commit_message>
Update pitch deck (add name to title slide) and rebuild 1:59 demo
- Re-export slides from updated Spec-RTL-Sentinel-Pitch.pptx
- Rebuild synced demo video to exactly 1:59, same voiceover + closing line

Co-authored-by: Copilot <223556219+Copilot@users.noreply.github.com>
</commit_message>
<xml_diff>
--- a/presentation/Spec-RTL-Sentinel-Pitch.pptx
+++ b/presentation/Spec-RTL-Sentinel-Pitch.pptx
@@ -127,22 +127,30 @@
   <pc:docChgLst>
     <pc:chgData name="Mayuresh Piske" userId="aeb3d3e9-2c13-446e-8fc0-83f22db42824" providerId="ADAL" clId="{76688486-0801-4EB8-8479-3CA377FA07D4}"/>
     <pc:docChg chg="undo custSel modSld">
-      <pc:chgData name="Mayuresh Piske" userId="aeb3d3e9-2c13-446e-8fc0-83f22db42824" providerId="ADAL" clId="{76688486-0801-4EB8-8479-3CA377FA07D4}" dt="2026-09-04T20:25:09.658" v="66" actId="20577"/>
+      <pc:chgData name="Mayuresh Piske" userId="aeb3d3e9-2c13-446e-8fc0-83f22db42824" providerId="ADAL" clId="{76688486-0801-4EB8-8479-3CA377FA07D4}" dt="2026-09-05T15:14:52.947" v="113" actId="404"/>
       <pc:docMkLst>
         <pc:docMk/>
       </pc:docMkLst>
-      <pc:sldChg chg="modSp mod">
-        <pc:chgData name="Mayuresh Piske" userId="aeb3d3e9-2c13-446e-8fc0-83f22db42824" providerId="ADAL" clId="{76688486-0801-4EB8-8479-3CA377FA07D4}" dt="2026-09-04T20:25:09.658" v="66" actId="20577"/>
+      <pc:sldChg chg="addSp modSp mod">
+        <pc:chgData name="Mayuresh Piske" userId="aeb3d3e9-2c13-446e-8fc0-83f22db42824" providerId="ADAL" clId="{76688486-0801-4EB8-8479-3CA377FA07D4}" dt="2026-09-05T15:14:52.947" v="113" actId="404"/>
         <pc:sldMkLst>
           <pc:docMk/>
           <pc:sldMk cId="0" sldId="256"/>
         </pc:sldMkLst>
         <pc:spChg chg="mod">
-          <ac:chgData name="Mayuresh Piske" userId="aeb3d3e9-2c13-446e-8fc0-83f22db42824" providerId="ADAL" clId="{76688486-0801-4EB8-8479-3CA377FA07D4}" dt="2026-09-04T20:25:09.658" v="66" actId="20577"/>
+          <ac:chgData name="Mayuresh Piske" userId="aeb3d3e9-2c13-446e-8fc0-83f22db42824" providerId="ADAL" clId="{76688486-0801-4EB8-8479-3CA377FA07D4}" dt="2026-09-05T15:14:40.267" v="104" actId="20577"/>
           <ac:spMkLst>
             <pc:docMk/>
             <pc:sldMk cId="0" sldId="256"/>
             <ac:spMk id="17" creationId="{00000000-0000-0000-0000-000000000000}"/>
+          </ac:spMkLst>
+        </pc:spChg>
+        <pc:spChg chg="add mod">
+          <ac:chgData name="Mayuresh Piske" userId="aeb3d3e9-2c13-446e-8fc0-83f22db42824" providerId="ADAL" clId="{76688486-0801-4EB8-8479-3CA377FA07D4}" dt="2026-09-05T15:14:52.947" v="113" actId="404"/>
+          <ac:spMkLst>
+            <pc:docMk/>
+            <pc:sldMk cId="0" sldId="256"/>
+            <ac:spMk id="19" creationId="{8731F071-4729-E9AF-C629-533D86DEBEA2}"/>
           </ac:spMkLst>
         </pc:spChg>
       </pc:sldChg>
@@ -2149,6 +2157,49 @@
               <a:t>Spec-faithful RTL verification, grounded in design intent</a:t>
             </a:r>
             <a:endParaRPr lang="en-US" sz="1400" dirty="0"/>
+          </a:p>
+        </p:txBody>
+      </p:sp>
+      <p:sp>
+        <p:nvSpPr>
+          <p:cNvPr id="19" name="TextBox 18">
+            <a:extLst>
+              <a:ext uri="{FF2B5EF4-FFF2-40B4-BE49-F238E27FC236}">
+                <a16:creationId xmlns:a16="http://schemas.microsoft.com/office/drawing/2014/main" id="{8731F071-4729-E9AF-C629-533D86DEBEA2}"/>
+              </a:ext>
+            </a:extLst>
+          </p:cNvPr>
+          <p:cNvSpPr txBox="1"/>
+          <p:nvPr/>
+        </p:nvSpPr>
+        <p:spPr>
+          <a:xfrm>
+            <a:off x="775048" y="5486400"/>
+            <a:ext cx="6097044" cy="338554"/>
+          </a:xfrm>
+          <a:prstGeom prst="rect">
+            <a:avLst/>
+          </a:prstGeom>
+          <a:noFill/>
+        </p:spPr>
+        <p:txBody>
+          <a:bodyPr wrap="square">
+            <a:spAutoFit/>
+          </a:bodyPr>
+          <a:lstStyle/>
+          <a:p>
+            <a:r>
+              <a:rPr lang="en-US" sz="1600" dirty="0">
+                <a:solidFill>
+                  <a:srgbClr val="9DB4CC"/>
+                </a:solidFill>
+                <a:latin typeface="Calibri" pitchFamily="34" charset="0"/>
+                <a:ea typeface="Calibri" pitchFamily="34" charset="-122"/>
+                <a:cs typeface="Calibri" pitchFamily="34" charset="-120"/>
+              </a:rPr>
+              <a:t>Mayuresh Piske </a:t>
+            </a:r>
+            <a:endParaRPr lang="en-IN" sz="2000" dirty="0"/>
           </a:p>
         </p:txBody>
       </p:sp>

</xml_diff>

<commit_message>
Update pitch deck (add footer) and rebuild 1:59 demo video
Co-authored-by: Copilot <223556219+Copilot@users.noreply.github.com>
</commit_message>
<xml_diff>
--- a/presentation/Spec-RTL-Sentinel-Pitch.pptx
+++ b/presentation/Spec-RTL-Sentinel-Pitch.pptx
@@ -1,6 +1,6 @@
 
 <file path=ppt/presentation.xml><?xml version="1.0" encoding="utf-8"?>
-<p:presentation xmlns:a="http://schemas.openxmlformats.org/drawingml/2006/main" xmlns:r="http://schemas.openxmlformats.org/officeDocument/2006/relationships" xmlns:p="http://schemas.openxmlformats.org/presentationml/2006/main" saveSubsetFonts="1" autoCompressPictures="0">
+<p:presentation xmlns:a="http://schemas.openxmlformats.org/drawingml/2006/main" xmlns:r="http://schemas.openxmlformats.org/officeDocument/2006/relationships" xmlns:p="http://schemas.openxmlformats.org/presentationml/2006/main" showSpecialPlsOnTitleSld="0" saveSubsetFonts="1" autoCompressPictures="0">
   <p:sldMasterIdLst>
     <p:sldMasterId id="2147483648" r:id="rId1"/>
   </p:sldMasterIdLst>
@@ -122,12 +122,20 @@
 </p:presentation>
 </file>
 
+<file path=ppt/revisionInfo.xml><?xml version="1.0" encoding="utf-8"?>
+<p1510:revInfo xmlns:a="http://schemas.openxmlformats.org/drawingml/2006/main" xmlns:r="http://schemas.openxmlformats.org/officeDocument/2006/relationships" xmlns:p1510="http://schemas.microsoft.com/office/powerpoint/2015/10/main">
+  <p1510:revLst>
+    <p1510:client id="{DCE515F7-15B9-4748-AAFB-6C386C242028}" v="1" dt="2026-09-05T15:31:46.691"/>
+  </p1510:revLst>
+</p1510:revInfo>
+</file>
+
 <file path=ppt/changesInfos/changesInfo1.xml><?xml version="1.0" encoding="utf-8"?>
 <pc:chgInfo xmlns:a="http://schemas.openxmlformats.org/drawingml/2006/main" xmlns:r="http://schemas.openxmlformats.org/officeDocument/2006/relationships" xmlns:ac="http://schemas.microsoft.com/office/drawing/2013/main/command" xmlns:pc="http://schemas.microsoft.com/office/powerpoint/2013/main/command">
   <pc:docChgLst>
     <pc:chgData name="Mayuresh Piske" userId="aeb3d3e9-2c13-446e-8fc0-83f22db42824" providerId="ADAL" clId="{76688486-0801-4EB8-8479-3CA377FA07D4}"/>
     <pc:docChg chg="undo custSel modSld">
-      <pc:chgData name="Mayuresh Piske" userId="aeb3d3e9-2c13-446e-8fc0-83f22db42824" providerId="ADAL" clId="{76688486-0801-4EB8-8479-3CA377FA07D4}" dt="2026-09-05T15:14:52.947" v="113" actId="404"/>
+      <pc:chgData name="Mayuresh Piske" userId="aeb3d3e9-2c13-446e-8fc0-83f22db42824" providerId="ADAL" clId="{76688486-0801-4EB8-8479-3CA377FA07D4}" dt="2026-09-05T15:34:31.937" v="134" actId="1076"/>
       <pc:docMkLst>
         <pc:docMk/>
       </pc:docMkLst>
@@ -154,12 +162,65 @@
           </ac:spMkLst>
         </pc:spChg>
       </pc:sldChg>
+      <pc:sldChg chg="addSp modSp mod">
+        <pc:chgData name="Mayuresh Piske" userId="aeb3d3e9-2c13-446e-8fc0-83f22db42824" providerId="ADAL" clId="{76688486-0801-4EB8-8479-3CA377FA07D4}" dt="2026-09-05T15:33:49.837" v="121" actId="14100"/>
+        <pc:sldMkLst>
+          <pc:docMk/>
+          <pc:sldMk cId="0" sldId="257"/>
+        </pc:sldMkLst>
+        <pc:spChg chg="add mod">
+          <ac:chgData name="Mayuresh Piske" userId="aeb3d3e9-2c13-446e-8fc0-83f22db42824" providerId="ADAL" clId="{76688486-0801-4EB8-8479-3CA377FA07D4}" dt="2026-09-05T15:33:49.837" v="121" actId="14100"/>
+          <ac:spMkLst>
+            <pc:docMk/>
+            <pc:sldMk cId="0" sldId="257"/>
+            <ac:spMk id="19" creationId="{7F27F073-B621-650F-84F3-C9DBD53DB2D0}"/>
+          </ac:spMkLst>
+        </pc:spChg>
+      </pc:sldChg>
+      <pc:sldChg chg="addSp mod">
+        <pc:chgData name="Mayuresh Piske" userId="aeb3d3e9-2c13-446e-8fc0-83f22db42824" providerId="ADAL" clId="{76688486-0801-4EB8-8479-3CA377FA07D4}" dt="2026-09-05T15:33:53.861" v="122" actId="22"/>
+        <pc:sldMkLst>
+          <pc:docMk/>
+          <pc:sldMk cId="0" sldId="258"/>
+        </pc:sldMkLst>
+        <pc:spChg chg="add">
+          <ac:chgData name="Mayuresh Piske" userId="aeb3d3e9-2c13-446e-8fc0-83f22db42824" providerId="ADAL" clId="{76688486-0801-4EB8-8479-3CA377FA07D4}" dt="2026-09-05T15:33:53.861" v="122" actId="22"/>
+          <ac:spMkLst>
+            <pc:docMk/>
+            <pc:sldMk cId="0" sldId="258"/>
+            <ac:spMk id="27" creationId="{6D3AE265-6647-D192-AFB8-DD3446F87356}"/>
+          </ac:spMkLst>
+        </pc:spChg>
+      </pc:sldChg>
+      <pc:sldChg chg="addSp mod">
+        <pc:chgData name="Mayuresh Piske" userId="aeb3d3e9-2c13-446e-8fc0-83f22db42824" providerId="ADAL" clId="{76688486-0801-4EB8-8479-3CA377FA07D4}" dt="2026-09-05T15:33:56.582" v="123" actId="22"/>
+        <pc:sldMkLst>
+          <pc:docMk/>
+          <pc:sldMk cId="0" sldId="259"/>
+        </pc:sldMkLst>
+        <pc:spChg chg="add">
+          <ac:chgData name="Mayuresh Piske" userId="aeb3d3e9-2c13-446e-8fc0-83f22db42824" providerId="ADAL" clId="{76688486-0801-4EB8-8479-3CA377FA07D4}" dt="2026-09-05T15:33:56.582" v="123" actId="22"/>
+          <ac:spMkLst>
+            <pc:docMk/>
+            <pc:sldMk cId="0" sldId="259"/>
+            <ac:spMk id="27" creationId="{F8849967-8F42-B486-2EE2-8F68F53C6908}"/>
+          </ac:spMkLst>
+        </pc:spChg>
+      </pc:sldChg>
       <pc:sldChg chg="addSp delSp modSp mod">
-        <pc:chgData name="Mayuresh Piske" userId="aeb3d3e9-2c13-446e-8fc0-83f22db42824" providerId="ADAL" clId="{76688486-0801-4EB8-8479-3CA377FA07D4}" dt="2026-09-04T19:27:45.856" v="3" actId="1076"/>
+        <pc:chgData name="Mayuresh Piske" userId="aeb3d3e9-2c13-446e-8fc0-83f22db42824" providerId="ADAL" clId="{76688486-0801-4EB8-8479-3CA377FA07D4}" dt="2026-09-05T15:33:58.190" v="124" actId="22"/>
         <pc:sldMkLst>
           <pc:docMk/>
           <pc:sldMk cId="0" sldId="260"/>
         </pc:sldMkLst>
+        <pc:spChg chg="add">
+          <ac:chgData name="Mayuresh Piske" userId="aeb3d3e9-2c13-446e-8fc0-83f22db42824" providerId="ADAL" clId="{76688486-0801-4EB8-8479-3CA377FA07D4}" dt="2026-09-05T15:33:58.190" v="124" actId="22"/>
+          <ac:spMkLst>
+            <pc:docMk/>
+            <pc:sldMk cId="0" sldId="260"/>
+            <ac:spMk id="7" creationId="{7FFE3023-7056-4330-C149-CB70C2849902}"/>
+          </ac:spMkLst>
+        </pc:spChg>
         <pc:picChg chg="del">
           <ac:chgData name="Mayuresh Piske" userId="aeb3d3e9-2c13-446e-8fc0-83f22db42824" providerId="ADAL" clId="{76688486-0801-4EB8-8479-3CA377FA07D4}" dt="2026-09-04T19:27:22.492" v="0" actId="478"/>
           <ac:picMkLst>
@@ -176,6 +237,112 @@
             <ac:picMk id="6" creationId="{465530B9-9763-EA4B-618B-C055AB3984BE}"/>
           </ac:picMkLst>
         </pc:picChg>
+      </pc:sldChg>
+      <pc:sldChg chg="addSp modSp mod">
+        <pc:chgData name="Mayuresh Piske" userId="aeb3d3e9-2c13-446e-8fc0-83f22db42824" providerId="ADAL" clId="{76688486-0801-4EB8-8479-3CA377FA07D4}" dt="2026-09-05T15:34:06.111" v="126" actId="1076"/>
+        <pc:sldMkLst>
+          <pc:docMk/>
+          <pc:sldMk cId="0" sldId="261"/>
+        </pc:sldMkLst>
+        <pc:spChg chg="mod">
+          <ac:chgData name="Mayuresh Piske" userId="aeb3d3e9-2c13-446e-8fc0-83f22db42824" providerId="ADAL" clId="{76688486-0801-4EB8-8479-3CA377FA07D4}" dt="2026-09-05T15:34:06.111" v="126" actId="1076"/>
+          <ac:spMkLst>
+            <pc:docMk/>
+            <pc:sldMk cId="0" sldId="261"/>
+            <ac:spMk id="41" creationId="{00000000-0000-0000-0000-000000000000}"/>
+          </ac:spMkLst>
+        </pc:spChg>
+        <pc:spChg chg="add">
+          <ac:chgData name="Mayuresh Piske" userId="aeb3d3e9-2c13-446e-8fc0-83f22db42824" providerId="ADAL" clId="{76688486-0801-4EB8-8479-3CA377FA07D4}" dt="2026-09-05T15:33:59.787" v="125" actId="22"/>
+          <ac:spMkLst>
+            <pc:docMk/>
+            <pc:sldMk cId="0" sldId="261"/>
+            <ac:spMk id="43" creationId="{EA485733-FEF1-127D-6C2C-3683286CBA9D}"/>
+          </ac:spMkLst>
+        </pc:spChg>
+      </pc:sldChg>
+      <pc:sldChg chg="addSp modSp mod">
+        <pc:chgData name="Mayuresh Piske" userId="aeb3d3e9-2c13-446e-8fc0-83f22db42824" providerId="ADAL" clId="{76688486-0801-4EB8-8479-3CA377FA07D4}" dt="2026-09-05T15:34:14.517" v="128" actId="1076"/>
+        <pc:sldMkLst>
+          <pc:docMk/>
+          <pc:sldMk cId="0" sldId="262"/>
+        </pc:sldMkLst>
+        <pc:spChg chg="add mod">
+          <ac:chgData name="Mayuresh Piske" userId="aeb3d3e9-2c13-446e-8fc0-83f22db42824" providerId="ADAL" clId="{76688486-0801-4EB8-8479-3CA377FA07D4}" dt="2026-09-05T15:34:14.517" v="128" actId="1076"/>
+          <ac:spMkLst>
+            <pc:docMk/>
+            <pc:sldMk cId="0" sldId="262"/>
+            <ac:spMk id="36" creationId="{DBC8F55F-6597-4454-AF48-7C488DFA6F06}"/>
+          </ac:spMkLst>
+        </pc:spChg>
+      </pc:sldChg>
+      <pc:sldChg chg="addSp mod">
+        <pc:chgData name="Mayuresh Piske" userId="aeb3d3e9-2c13-446e-8fc0-83f22db42824" providerId="ADAL" clId="{76688486-0801-4EB8-8479-3CA377FA07D4}" dt="2026-09-05T15:34:16.766" v="129" actId="22"/>
+        <pc:sldMkLst>
+          <pc:docMk/>
+          <pc:sldMk cId="0" sldId="263"/>
+        </pc:sldMkLst>
+        <pc:spChg chg="add">
+          <ac:chgData name="Mayuresh Piske" userId="aeb3d3e9-2c13-446e-8fc0-83f22db42824" providerId="ADAL" clId="{76688486-0801-4EB8-8479-3CA377FA07D4}" dt="2026-09-05T15:34:16.766" v="129" actId="22"/>
+          <ac:spMkLst>
+            <pc:docMk/>
+            <pc:sldMk cId="0" sldId="263"/>
+            <ac:spMk id="39" creationId="{1B3666CF-A2EF-84AD-6DBB-8D719F336E2E}"/>
+          </ac:spMkLst>
+        </pc:spChg>
+      </pc:sldChg>
+      <pc:sldChg chg="addSp mod">
+        <pc:chgData name="Mayuresh Piske" userId="aeb3d3e9-2c13-446e-8fc0-83f22db42824" providerId="ADAL" clId="{76688486-0801-4EB8-8479-3CA377FA07D4}" dt="2026-09-05T15:34:18.985" v="130" actId="22"/>
+        <pc:sldMkLst>
+          <pc:docMk/>
+          <pc:sldMk cId="0" sldId="264"/>
+        </pc:sldMkLst>
+        <pc:spChg chg="add">
+          <ac:chgData name="Mayuresh Piske" userId="aeb3d3e9-2c13-446e-8fc0-83f22db42824" providerId="ADAL" clId="{76688486-0801-4EB8-8479-3CA377FA07D4}" dt="2026-09-05T15:34:18.985" v="130" actId="22"/>
+          <ac:spMkLst>
+            <pc:docMk/>
+            <pc:sldMk cId="0" sldId="264"/>
+            <ac:spMk id="21" creationId="{46076EF9-0F0A-0BFF-2845-4220C41BB9A6}"/>
+          </ac:spMkLst>
+        </pc:spChg>
+      </pc:sldChg>
+      <pc:sldChg chg="addSp mod">
+        <pc:chgData name="Mayuresh Piske" userId="aeb3d3e9-2c13-446e-8fc0-83f22db42824" providerId="ADAL" clId="{76688486-0801-4EB8-8479-3CA377FA07D4}" dt="2026-09-05T15:34:20.874" v="131" actId="22"/>
+        <pc:sldMkLst>
+          <pc:docMk/>
+          <pc:sldMk cId="0" sldId="265"/>
+        </pc:sldMkLst>
+        <pc:spChg chg="add">
+          <ac:chgData name="Mayuresh Piske" userId="aeb3d3e9-2c13-446e-8fc0-83f22db42824" providerId="ADAL" clId="{76688486-0801-4EB8-8479-3CA377FA07D4}" dt="2026-09-05T15:34:20.874" v="131" actId="22"/>
+          <ac:spMkLst>
+            <pc:docMk/>
+            <pc:sldMk cId="0" sldId="265"/>
+            <ac:spMk id="17" creationId="{0B101354-6E19-8B85-FBF1-D52CA88A748E}"/>
+          </ac:spMkLst>
+        </pc:spChg>
+      </pc:sldChg>
+      <pc:sldChg chg="addSp modSp mod">
+        <pc:chgData name="Mayuresh Piske" userId="aeb3d3e9-2c13-446e-8fc0-83f22db42824" providerId="ADAL" clId="{76688486-0801-4EB8-8479-3CA377FA07D4}" dt="2026-09-05T15:34:31.937" v="134" actId="1076"/>
+        <pc:sldMkLst>
+          <pc:docMk/>
+          <pc:sldMk cId="0" sldId="266"/>
+        </pc:sldMkLst>
+        <pc:spChg chg="mod">
+          <ac:chgData name="Mayuresh Piske" userId="aeb3d3e9-2c13-446e-8fc0-83f22db42824" providerId="ADAL" clId="{76688486-0801-4EB8-8479-3CA377FA07D4}" dt="2026-09-05T15:34:28.030" v="133" actId="1076"/>
+          <ac:spMkLst>
+            <pc:docMk/>
+            <pc:sldMk cId="0" sldId="266"/>
+            <ac:spMk id="10" creationId="{00000000-0000-0000-0000-000000000000}"/>
+          </ac:spMkLst>
+        </pc:spChg>
+        <pc:spChg chg="add mod">
+          <ac:chgData name="Mayuresh Piske" userId="aeb3d3e9-2c13-446e-8fc0-83f22db42824" providerId="ADAL" clId="{76688486-0801-4EB8-8479-3CA377FA07D4}" dt="2026-09-05T15:34:31.937" v="134" actId="1076"/>
+          <ac:spMkLst>
+            <pc:docMk/>
+            <pc:sldMk cId="0" sldId="266"/>
+            <ac:spMk id="12" creationId="{808BB909-71BB-0DB8-31C1-52D29251FAFD}"/>
+          </ac:spMkLst>
+        </pc:spChg>
       </pc:sldChg>
     </pc:docChg>
   </pc:docChgLst>
@@ -1289,7 +1456,7 @@
   <p:sldLayoutIdLst>
     <p:sldLayoutId id="2147483649" r:id="rId1"/>
   </p:sldLayoutIdLst>
-  <p:hf sldNum="0" hdr="0" ftr="0" dt="0"/>
+  <p:hf hdr="0" dt="0"/>
   <p:txStyles>
     <p:titleStyle>
       <a:lvl1pPr algn="ctr" defTabSz="914400" rtl="0" eaLnBrk="1" latinLnBrk="0" hangingPunct="1">
@@ -2855,6 +3022,67 @@
           </a:p>
         </p:txBody>
       </p:sp>
+      <p:sp>
+        <p:nvSpPr>
+          <p:cNvPr id="17" name="TextBox 16">
+            <a:extLst>
+              <a:ext uri="{FF2B5EF4-FFF2-40B4-BE49-F238E27FC236}">
+                <a16:creationId xmlns:a16="http://schemas.microsoft.com/office/drawing/2014/main" id="{0B101354-6E19-8B85-FBF1-D52CA88A748E}"/>
+              </a:ext>
+            </a:extLst>
+          </p:cNvPr>
+          <p:cNvSpPr txBox="1"/>
+          <p:nvPr/>
+        </p:nvSpPr>
+        <p:spPr>
+          <a:xfrm>
+            <a:off x="161273" y="6488668"/>
+            <a:ext cx="2249987" cy="261610"/>
+          </a:xfrm>
+          <a:prstGeom prst="rect">
+            <a:avLst/>
+          </a:prstGeom>
+          <a:noFill/>
+        </p:spPr>
+        <p:txBody>
+          <a:bodyPr wrap="square">
+            <a:spAutoFit/>
+          </a:bodyPr>
+          <a:lstStyle/>
+          <a:p>
+            <a:r>
+              <a:rPr lang="en-IN" sz="1100" dirty="0">
+                <a:solidFill>
+                  <a:schemeClr val="bg2">
+                    <a:lumMod val="75000"/>
+                  </a:schemeClr>
+                </a:solidFill>
+              </a:rPr>
+              <a:t>spec-</a:t>
+            </a:r>
+            <a:r>
+              <a:rPr lang="en-IN" sz="1100" dirty="0" err="1">
+                <a:solidFill>
+                  <a:schemeClr val="bg2">
+                    <a:lumMod val="75000"/>
+                  </a:schemeClr>
+                </a:solidFill>
+              </a:rPr>
+              <a:t>rtl</a:t>
+            </a:r>
+            <a:r>
+              <a:rPr lang="en-IN" sz="1100" dirty="0">
+                <a:solidFill>
+                  <a:schemeClr val="bg2">
+                    <a:lumMod val="75000"/>
+                  </a:schemeClr>
+                </a:solidFill>
+              </a:rPr>
+              <a:t>-sentinel · © 2026 Microsoft</a:t>
+            </a:r>
+          </a:p>
+        </p:txBody>
+      </p:sp>
     </p:spTree>
   </p:cSld>
   <p:clrMapOvr>
@@ -3257,7 +3485,7 @@
         </p:nvSpPr>
         <p:spPr>
           <a:xfrm>
-            <a:off x="822960" y="6355080"/>
+            <a:off x="868680" y="6203515"/>
             <a:ext cx="10607040" cy="365760"/>
           </a:xfrm>
           <a:prstGeom prst="rect">
@@ -3285,6 +3513,67 @@
               <a:t>Spec-RTL Sentinel — catching spec-to-silicon drift before it becomes a bug.</a:t>
             </a:r>
             <a:endParaRPr lang="en-US" sz="1300" dirty="0"/>
+          </a:p>
+        </p:txBody>
+      </p:sp>
+      <p:sp>
+        <p:nvSpPr>
+          <p:cNvPr id="12" name="TextBox 11">
+            <a:extLst>
+              <a:ext uri="{FF2B5EF4-FFF2-40B4-BE49-F238E27FC236}">
+                <a16:creationId xmlns:a16="http://schemas.microsoft.com/office/drawing/2014/main" id="{808BB909-71BB-0DB8-31C1-52D29251FAFD}"/>
+              </a:ext>
+            </a:extLst>
+          </p:cNvPr>
+          <p:cNvSpPr txBox="1"/>
+          <p:nvPr/>
+        </p:nvSpPr>
+        <p:spPr>
+          <a:xfrm>
+            <a:off x="305322" y="6565077"/>
+            <a:ext cx="2249987" cy="261610"/>
+          </a:xfrm>
+          <a:prstGeom prst="rect">
+            <a:avLst/>
+          </a:prstGeom>
+          <a:noFill/>
+        </p:spPr>
+        <p:txBody>
+          <a:bodyPr wrap="square">
+            <a:spAutoFit/>
+          </a:bodyPr>
+          <a:lstStyle/>
+          <a:p>
+            <a:r>
+              <a:rPr lang="en-IN" sz="1100" dirty="0">
+                <a:solidFill>
+                  <a:schemeClr val="bg2">
+                    <a:lumMod val="75000"/>
+                  </a:schemeClr>
+                </a:solidFill>
+              </a:rPr>
+              <a:t>spec-</a:t>
+            </a:r>
+            <a:r>
+              <a:rPr lang="en-IN" sz="1100" dirty="0" err="1">
+                <a:solidFill>
+                  <a:schemeClr val="bg2">
+                    <a:lumMod val="75000"/>
+                  </a:schemeClr>
+                </a:solidFill>
+              </a:rPr>
+              <a:t>rtl</a:t>
+            </a:r>
+            <a:r>
+              <a:rPr lang="en-IN" sz="1100" dirty="0">
+                <a:solidFill>
+                  <a:schemeClr val="bg2">
+                    <a:lumMod val="75000"/>
+                  </a:schemeClr>
+                </a:solidFill>
+              </a:rPr>
+              <a:t>-sentinel · © 2026 Microsoft</a:t>
+            </a:r>
           </a:p>
         </p:txBody>
       </p:sp>
@@ -3982,6 +4271,67 @@
           </a:p>
         </p:txBody>
       </p:sp>
+      <p:sp>
+        <p:nvSpPr>
+          <p:cNvPr id="19" name="TextBox 18">
+            <a:extLst>
+              <a:ext uri="{FF2B5EF4-FFF2-40B4-BE49-F238E27FC236}">
+                <a16:creationId xmlns:a16="http://schemas.microsoft.com/office/drawing/2014/main" id="{7F27F073-B621-650F-84F3-C9DBD53DB2D0}"/>
+              </a:ext>
+            </a:extLst>
+          </p:cNvPr>
+          <p:cNvSpPr txBox="1"/>
+          <p:nvPr/>
+        </p:nvSpPr>
+        <p:spPr>
+          <a:xfrm>
+            <a:off x="161273" y="6488668"/>
+            <a:ext cx="2249987" cy="261610"/>
+          </a:xfrm>
+          <a:prstGeom prst="rect">
+            <a:avLst/>
+          </a:prstGeom>
+          <a:noFill/>
+        </p:spPr>
+        <p:txBody>
+          <a:bodyPr wrap="square">
+            <a:spAutoFit/>
+          </a:bodyPr>
+          <a:lstStyle/>
+          <a:p>
+            <a:r>
+              <a:rPr lang="en-IN" sz="1100" dirty="0">
+                <a:solidFill>
+                  <a:schemeClr val="bg2">
+                    <a:lumMod val="75000"/>
+                  </a:schemeClr>
+                </a:solidFill>
+              </a:rPr>
+              <a:t>spec-</a:t>
+            </a:r>
+            <a:r>
+              <a:rPr lang="en-IN" sz="1100" dirty="0" err="1">
+                <a:solidFill>
+                  <a:schemeClr val="bg2">
+                    <a:lumMod val="75000"/>
+                  </a:schemeClr>
+                </a:solidFill>
+              </a:rPr>
+              <a:t>rtl</a:t>
+            </a:r>
+            <a:r>
+              <a:rPr lang="en-IN" sz="1100" dirty="0">
+                <a:solidFill>
+                  <a:schemeClr val="bg2">
+                    <a:lumMod val="75000"/>
+                  </a:schemeClr>
+                </a:solidFill>
+              </a:rPr>
+              <a:t>-sentinel · © 2026 Microsoft</a:t>
+            </a:r>
+          </a:p>
+        </p:txBody>
+      </p:sp>
     </p:spTree>
   </p:cSld>
   <p:clrMapOvr>
@@ -4878,6 +5228,67 @@
           </a:p>
         </p:txBody>
       </p:sp>
+      <p:sp>
+        <p:nvSpPr>
+          <p:cNvPr id="27" name="TextBox 26">
+            <a:extLst>
+              <a:ext uri="{FF2B5EF4-FFF2-40B4-BE49-F238E27FC236}">
+                <a16:creationId xmlns:a16="http://schemas.microsoft.com/office/drawing/2014/main" id="{6D3AE265-6647-D192-AFB8-DD3446F87356}"/>
+              </a:ext>
+            </a:extLst>
+          </p:cNvPr>
+          <p:cNvSpPr txBox="1"/>
+          <p:nvPr/>
+        </p:nvSpPr>
+        <p:spPr>
+          <a:xfrm>
+            <a:off x="161273" y="6488668"/>
+            <a:ext cx="2249987" cy="261610"/>
+          </a:xfrm>
+          <a:prstGeom prst="rect">
+            <a:avLst/>
+          </a:prstGeom>
+          <a:noFill/>
+        </p:spPr>
+        <p:txBody>
+          <a:bodyPr wrap="square">
+            <a:spAutoFit/>
+          </a:bodyPr>
+          <a:lstStyle/>
+          <a:p>
+            <a:r>
+              <a:rPr lang="en-IN" sz="1100" dirty="0">
+                <a:solidFill>
+                  <a:schemeClr val="bg2">
+                    <a:lumMod val="75000"/>
+                  </a:schemeClr>
+                </a:solidFill>
+              </a:rPr>
+              <a:t>spec-</a:t>
+            </a:r>
+            <a:r>
+              <a:rPr lang="en-IN" sz="1100" dirty="0" err="1">
+                <a:solidFill>
+                  <a:schemeClr val="bg2">
+                    <a:lumMod val="75000"/>
+                  </a:schemeClr>
+                </a:solidFill>
+              </a:rPr>
+              <a:t>rtl</a:t>
+            </a:r>
+            <a:r>
+              <a:rPr lang="en-IN" sz="1100" dirty="0">
+                <a:solidFill>
+                  <a:schemeClr val="bg2">
+                    <a:lumMod val="75000"/>
+                  </a:schemeClr>
+                </a:solidFill>
+              </a:rPr>
+              <a:t>-sentinel · © 2026 Microsoft</a:t>
+            </a:r>
+          </a:p>
+        </p:txBody>
+      </p:sp>
     </p:spTree>
   </p:cSld>
   <p:clrMapOvr>
@@ -5795,6 +6206,67 @@
           </a:p>
         </p:txBody>
       </p:sp>
+      <p:sp>
+        <p:nvSpPr>
+          <p:cNvPr id="27" name="TextBox 26">
+            <a:extLst>
+              <a:ext uri="{FF2B5EF4-FFF2-40B4-BE49-F238E27FC236}">
+                <a16:creationId xmlns:a16="http://schemas.microsoft.com/office/drawing/2014/main" id="{F8849967-8F42-B486-2EE2-8F68F53C6908}"/>
+              </a:ext>
+            </a:extLst>
+          </p:cNvPr>
+          <p:cNvSpPr txBox="1"/>
+          <p:nvPr/>
+        </p:nvSpPr>
+        <p:spPr>
+          <a:xfrm>
+            <a:off x="161273" y="6488668"/>
+            <a:ext cx="2249987" cy="261610"/>
+          </a:xfrm>
+          <a:prstGeom prst="rect">
+            <a:avLst/>
+          </a:prstGeom>
+          <a:noFill/>
+        </p:spPr>
+        <p:txBody>
+          <a:bodyPr wrap="square">
+            <a:spAutoFit/>
+          </a:bodyPr>
+          <a:lstStyle/>
+          <a:p>
+            <a:r>
+              <a:rPr lang="en-IN" sz="1100" dirty="0">
+                <a:solidFill>
+                  <a:schemeClr val="bg2">
+                    <a:lumMod val="75000"/>
+                  </a:schemeClr>
+                </a:solidFill>
+              </a:rPr>
+              <a:t>spec-</a:t>
+            </a:r>
+            <a:r>
+              <a:rPr lang="en-IN" sz="1100" dirty="0" err="1">
+                <a:solidFill>
+                  <a:schemeClr val="bg2">
+                    <a:lumMod val="75000"/>
+                  </a:schemeClr>
+                </a:solidFill>
+              </a:rPr>
+              <a:t>rtl</a:t>
+            </a:r>
+            <a:r>
+              <a:rPr lang="en-IN" sz="1100" dirty="0">
+                <a:solidFill>
+                  <a:schemeClr val="bg2">
+                    <a:lumMod val="75000"/>
+                  </a:schemeClr>
+                </a:solidFill>
+              </a:rPr>
+              <a:t>-sentinel · © 2026 Microsoft</a:t>
+            </a:r>
+          </a:p>
+        </p:txBody>
+      </p:sp>
     </p:spTree>
   </p:cSld>
   <p:clrMapOvr>
@@ -5963,6 +6435,67 @@
           </a:prstGeom>
         </p:spPr>
       </p:pic>
+      <p:sp>
+        <p:nvSpPr>
+          <p:cNvPr id="7" name="TextBox 6">
+            <a:extLst>
+              <a:ext uri="{FF2B5EF4-FFF2-40B4-BE49-F238E27FC236}">
+                <a16:creationId xmlns:a16="http://schemas.microsoft.com/office/drawing/2014/main" id="{7FFE3023-7056-4330-C149-CB70C2849902}"/>
+              </a:ext>
+            </a:extLst>
+          </p:cNvPr>
+          <p:cNvSpPr txBox="1"/>
+          <p:nvPr/>
+        </p:nvSpPr>
+        <p:spPr>
+          <a:xfrm>
+            <a:off x="161273" y="6488668"/>
+            <a:ext cx="2249987" cy="261610"/>
+          </a:xfrm>
+          <a:prstGeom prst="rect">
+            <a:avLst/>
+          </a:prstGeom>
+          <a:noFill/>
+        </p:spPr>
+        <p:txBody>
+          <a:bodyPr wrap="square">
+            <a:spAutoFit/>
+          </a:bodyPr>
+          <a:lstStyle/>
+          <a:p>
+            <a:r>
+              <a:rPr lang="en-IN" sz="1100" dirty="0">
+                <a:solidFill>
+                  <a:schemeClr val="bg2">
+                    <a:lumMod val="75000"/>
+                  </a:schemeClr>
+                </a:solidFill>
+              </a:rPr>
+              <a:t>spec-</a:t>
+            </a:r>
+            <a:r>
+              <a:rPr lang="en-IN" sz="1100" dirty="0" err="1">
+                <a:solidFill>
+                  <a:schemeClr val="bg2">
+                    <a:lumMod val="75000"/>
+                  </a:schemeClr>
+                </a:solidFill>
+              </a:rPr>
+              <a:t>rtl</a:t>
+            </a:r>
+            <a:r>
+              <a:rPr lang="en-IN" sz="1100" dirty="0">
+                <a:solidFill>
+                  <a:schemeClr val="bg2">
+                    <a:lumMod val="75000"/>
+                  </a:schemeClr>
+                </a:solidFill>
+              </a:rPr>
+              <a:t>-sentinel · © 2026 Microsoft</a:t>
+            </a:r>
+          </a:p>
+        </p:txBody>
+      </p:sp>
     </p:spTree>
   </p:cSld>
   <p:clrMapOvr>
@@ -7423,7 +7956,7 @@
         </p:nvSpPr>
         <p:spPr>
           <a:xfrm>
-            <a:off x="640080" y="6400800"/>
+            <a:off x="694944" y="6241187"/>
             <a:ext cx="10881360" cy="365760"/>
           </a:xfrm>
           <a:prstGeom prst="rect">
@@ -7451,6 +7984,67 @@
               <a:t>All grounded in a dependency-free multi-source RAG store — runs fully offline.</a:t>
             </a:r>
             <a:endParaRPr lang="en-US" sz="1300" dirty="0"/>
+          </a:p>
+        </p:txBody>
+      </p:sp>
+      <p:sp>
+        <p:nvSpPr>
+          <p:cNvPr id="43" name="TextBox 42">
+            <a:extLst>
+              <a:ext uri="{FF2B5EF4-FFF2-40B4-BE49-F238E27FC236}">
+                <a16:creationId xmlns:a16="http://schemas.microsoft.com/office/drawing/2014/main" id="{EA485733-FEF1-127D-6C2C-3683286CBA9D}"/>
+              </a:ext>
+            </a:extLst>
+          </p:cNvPr>
+          <p:cNvSpPr txBox="1"/>
+          <p:nvPr/>
+        </p:nvSpPr>
+        <p:spPr>
+          <a:xfrm>
+            <a:off x="161273" y="6488668"/>
+            <a:ext cx="2249987" cy="261610"/>
+          </a:xfrm>
+          <a:prstGeom prst="rect">
+            <a:avLst/>
+          </a:prstGeom>
+          <a:noFill/>
+        </p:spPr>
+        <p:txBody>
+          <a:bodyPr wrap="square">
+            <a:spAutoFit/>
+          </a:bodyPr>
+          <a:lstStyle/>
+          <a:p>
+            <a:r>
+              <a:rPr lang="en-IN" sz="1100" dirty="0">
+                <a:solidFill>
+                  <a:schemeClr val="bg2">
+                    <a:lumMod val="75000"/>
+                  </a:schemeClr>
+                </a:solidFill>
+              </a:rPr>
+              <a:t>spec-</a:t>
+            </a:r>
+            <a:r>
+              <a:rPr lang="en-IN" sz="1100" dirty="0" err="1">
+                <a:solidFill>
+                  <a:schemeClr val="bg2">
+                    <a:lumMod val="75000"/>
+                  </a:schemeClr>
+                </a:solidFill>
+              </a:rPr>
+              <a:t>rtl</a:t>
+            </a:r>
+            <a:r>
+              <a:rPr lang="en-IN" sz="1100" dirty="0">
+                <a:solidFill>
+                  <a:schemeClr val="bg2">
+                    <a:lumMod val="75000"/>
+                  </a:schemeClr>
+                </a:solidFill>
+              </a:rPr>
+              <a:t>-sentinel · © 2026 Microsoft</a:t>
+            </a:r>
           </a:p>
         </p:txBody>
       </p:sp>
@@ -8745,6 +9339,67 @@
           </a:p>
         </p:txBody>
       </p:sp>
+      <p:sp>
+        <p:nvSpPr>
+          <p:cNvPr id="36" name="TextBox 35">
+            <a:extLst>
+              <a:ext uri="{FF2B5EF4-FFF2-40B4-BE49-F238E27FC236}">
+                <a16:creationId xmlns:a16="http://schemas.microsoft.com/office/drawing/2014/main" id="{DBC8F55F-6597-4454-AF48-7C488DFA6F06}"/>
+              </a:ext>
+            </a:extLst>
+          </p:cNvPr>
+          <p:cNvSpPr txBox="1"/>
+          <p:nvPr/>
+        </p:nvSpPr>
+        <p:spPr>
+          <a:xfrm>
+            <a:off x="92380" y="6583680"/>
+            <a:ext cx="2249987" cy="261610"/>
+          </a:xfrm>
+          <a:prstGeom prst="rect">
+            <a:avLst/>
+          </a:prstGeom>
+          <a:noFill/>
+        </p:spPr>
+        <p:txBody>
+          <a:bodyPr wrap="square">
+            <a:spAutoFit/>
+          </a:bodyPr>
+          <a:lstStyle/>
+          <a:p>
+            <a:r>
+              <a:rPr lang="en-IN" sz="1100" dirty="0">
+                <a:solidFill>
+                  <a:schemeClr val="bg2">
+                    <a:lumMod val="75000"/>
+                  </a:schemeClr>
+                </a:solidFill>
+              </a:rPr>
+              <a:t>spec-</a:t>
+            </a:r>
+            <a:r>
+              <a:rPr lang="en-IN" sz="1100" dirty="0" err="1">
+                <a:solidFill>
+                  <a:schemeClr val="bg2">
+                    <a:lumMod val="75000"/>
+                  </a:schemeClr>
+                </a:solidFill>
+              </a:rPr>
+              <a:t>rtl</a:t>
+            </a:r>
+            <a:r>
+              <a:rPr lang="en-IN" sz="1100" dirty="0">
+                <a:solidFill>
+                  <a:schemeClr val="bg2">
+                    <a:lumMod val="75000"/>
+                  </a:schemeClr>
+                </a:solidFill>
+              </a:rPr>
+              <a:t>-sentinel · © 2026 Microsoft</a:t>
+            </a:r>
+          </a:p>
+        </p:txBody>
+      </p:sp>
     </p:spTree>
   </p:cSld>
   <p:clrMapOvr>
@@ -10111,6 +10766,67 @@
           </a:p>
         </p:txBody>
       </p:sp>
+      <p:sp>
+        <p:nvSpPr>
+          <p:cNvPr id="39" name="TextBox 38">
+            <a:extLst>
+              <a:ext uri="{FF2B5EF4-FFF2-40B4-BE49-F238E27FC236}">
+                <a16:creationId xmlns:a16="http://schemas.microsoft.com/office/drawing/2014/main" id="{1B3666CF-A2EF-84AD-6DBB-8D719F336E2E}"/>
+              </a:ext>
+            </a:extLst>
+          </p:cNvPr>
+          <p:cNvSpPr txBox="1"/>
+          <p:nvPr/>
+        </p:nvSpPr>
+        <p:spPr>
+          <a:xfrm>
+            <a:off x="161273" y="6488668"/>
+            <a:ext cx="2249987" cy="261610"/>
+          </a:xfrm>
+          <a:prstGeom prst="rect">
+            <a:avLst/>
+          </a:prstGeom>
+          <a:noFill/>
+        </p:spPr>
+        <p:txBody>
+          <a:bodyPr wrap="square">
+            <a:spAutoFit/>
+          </a:bodyPr>
+          <a:lstStyle/>
+          <a:p>
+            <a:r>
+              <a:rPr lang="en-IN" sz="1100" dirty="0">
+                <a:solidFill>
+                  <a:schemeClr val="bg2">
+                    <a:lumMod val="75000"/>
+                  </a:schemeClr>
+                </a:solidFill>
+              </a:rPr>
+              <a:t>spec-</a:t>
+            </a:r>
+            <a:r>
+              <a:rPr lang="en-IN" sz="1100" dirty="0" err="1">
+                <a:solidFill>
+                  <a:schemeClr val="bg2">
+                    <a:lumMod val="75000"/>
+                  </a:schemeClr>
+                </a:solidFill>
+              </a:rPr>
+              <a:t>rtl</a:t>
+            </a:r>
+            <a:r>
+              <a:rPr lang="en-IN" sz="1100" dirty="0">
+                <a:solidFill>
+                  <a:schemeClr val="bg2">
+                    <a:lumMod val="75000"/>
+                  </a:schemeClr>
+                </a:solidFill>
+              </a:rPr>
+              <a:t>-sentinel · © 2026 Microsoft</a:t>
+            </a:r>
+          </a:p>
+        </p:txBody>
+      </p:sp>
     </p:spTree>
   </p:cSld>
   <p:clrMapOvr>
@@ -10801,6 +11517,67 @@
               <a:t>Each result links to the exact HAS/MAS clause or decision it is grounded in. No hallucinations.</a:t>
             </a:r>
             <a:endParaRPr lang="en-US" sz="1400" dirty="0"/>
+          </a:p>
+        </p:txBody>
+      </p:sp>
+      <p:sp>
+        <p:nvSpPr>
+          <p:cNvPr id="21" name="TextBox 20">
+            <a:extLst>
+              <a:ext uri="{FF2B5EF4-FFF2-40B4-BE49-F238E27FC236}">
+                <a16:creationId xmlns:a16="http://schemas.microsoft.com/office/drawing/2014/main" id="{46076EF9-0F0A-0BFF-2845-4220C41BB9A6}"/>
+              </a:ext>
+            </a:extLst>
+          </p:cNvPr>
+          <p:cNvSpPr txBox="1"/>
+          <p:nvPr/>
+        </p:nvSpPr>
+        <p:spPr>
+          <a:xfrm>
+            <a:off x="161273" y="6488668"/>
+            <a:ext cx="2249987" cy="261610"/>
+          </a:xfrm>
+          <a:prstGeom prst="rect">
+            <a:avLst/>
+          </a:prstGeom>
+          <a:noFill/>
+        </p:spPr>
+        <p:txBody>
+          <a:bodyPr wrap="square">
+            <a:spAutoFit/>
+          </a:bodyPr>
+          <a:lstStyle/>
+          <a:p>
+            <a:r>
+              <a:rPr lang="en-IN" sz="1100" dirty="0">
+                <a:solidFill>
+                  <a:schemeClr val="bg2">
+                    <a:lumMod val="75000"/>
+                  </a:schemeClr>
+                </a:solidFill>
+              </a:rPr>
+              <a:t>spec-</a:t>
+            </a:r>
+            <a:r>
+              <a:rPr lang="en-IN" sz="1100" dirty="0" err="1">
+                <a:solidFill>
+                  <a:schemeClr val="bg2">
+                    <a:lumMod val="75000"/>
+                  </a:schemeClr>
+                </a:solidFill>
+              </a:rPr>
+              <a:t>rtl</a:t>
+            </a:r>
+            <a:r>
+              <a:rPr lang="en-IN" sz="1100" dirty="0">
+                <a:solidFill>
+                  <a:schemeClr val="bg2">
+                    <a:lumMod val="75000"/>
+                  </a:schemeClr>
+                </a:solidFill>
+              </a:rPr>
+              <a:t>-sentinel · © 2026 Microsoft</a:t>
+            </a:r>
           </a:p>
         </p:txBody>
       </p:sp>

</xml_diff>